<commit_message>
Add full speaker scripts to slides 2-9; larger type, tighter bullets
Speaker notes on the problem statement, four study summaries, objectives
and both methodology slides are now complete verbatim scripts with a
timing estimate, a transition line, and the likely question plus its
answer. They are what gets said, not a reminder of what to say.

Typography: body and bullet text raised roughly two points throughout -
QA showed the densest text box only 67 0.000000ull, so there was room. Bullet
indent cut from the pptxgenjs default of ~27pt to 10pt, and paragraph
spacing from 7 to 4, which removes the gap between the bullet and its
text that made dense slides look loose.

Validation clean; geometry QA clean at 16 slides under Montserrat
metrics.

Co-Authored-By: Claude Opus 5 <noreply@anthropic.com>
</commit_message>
<xml_diff>
--- a/docs/Graph_of_Thoughts_BTP_v4.pptx
+++ b/docs/Graph_of_Thoughts_BTP_v4.pptx
@@ -1952,7 +1952,16 @@
           <a:p>
             <a:r>
               <a:rPr lang="en-US" dirty="0"/>
-              <a:t>Frame the problem as cost, not capability. The structural advantage of graph reasoning is established; what is not established is that anyone can afford it.</a:t>
+              <a:t>SCRIPT  (~75 sec)
+Language models spend identical computation on every token. They cannot think harder on a harder question, and once a token is sampled everything after it is conditioned on that choice. So asking directly gives an arbitrarily hard problem one token's worth of computation.
+Structured prompting fixes that by generating intermediate thoughts - and Graph of Thoughts generates the most, because it can merge separate lines of reasoning.
+The problem is what that costs. On the right are our measurements: 64-element sorting, Qwen2.5-7B, a hundred instances. Graph of Thoughts consumes seven thousand nine hundred tokens per instance against five hundred and twenty for direct prompting. Fifteen times. And three and a half times Tree of Thoughts.
+That price would be acceptable if it bought accuracy. At this scale it does not - Tree of Thoughts scores eleven percent better for a third of the cost. So the most structurally capable scheme is currently the worst deal available.
+And you cannot simply turn the cost down. We measured that too: cutting cost ninefold raises the error above the level you get with no reasoning structure at all. Uniform pruning removes useful and redundant computation at the same rate.
+So our statement is: compress the reasoning graph - fewer vertices, and fewer tokens per vertex - while preserving the causal dependencies that carry information to the answer.
+---
+CUE: pause on the cost bars before reading the Statement.
+IF ASKED why 15x is a problem: it is the barrier to anyone deploying this, and at 7B it does not even buy accuracy.</a:t>
             </a:r>
             <a:endParaRPr lang="en-US" dirty="0"/>
           </a:p>
@@ -2040,7 +2049,15 @@
           <a:p>
             <a:r>
               <a:rPr lang="en-US" dirty="0"/>
-              <a:t>The foundational result. The emergence threshold matters for us: it explains why our 7B experiments behave differently from the paper's GPT-3.5 results.</a:t>
+              <a:t>SCRIPT  (~45 sec)
+Chain-of-Thought is the foundation. You add worked examples to the prompt showing intermediate steps, and the model imitates that - with no change to the weights at all. So this is purely inference-time, which is true of everything in this project.
+The key insight is that the chain is not the model explaining itself afterwards. The chain IS the computation. A model does one forward pass per token, so a one-token answer gets one token's worth of thinking no matter how hard the question. Fifty reasoning tokens gets fifty forward passes.
+And it works: GSM8K goes from eighteen percent to fifty-seven percent on PaLM-540B. That beat a fine-tuned model with a verifier, by prompting alone.
+One caveat that matters for our results later. The ability is emergent. Below roughly ten billion parameters the chains are fluent but logically invalid, and accuracy can drop below direct prompting. We are running a 7B model, so we will come back to this.
+The structural limitation is on the right. One path, each step with a single parent. Once a step is wrong, everything after it is conditioned on that error - there is no way to back out.
+---
+TRANSITION: That is what Tree of Thoughts addresses.
+CUE: the emergence bullet is load-bearing - it explains CoT scoring below IO on slide 11.</a:t>
             </a:r>
             <a:endParaRPr lang="en-US" dirty="0"/>
           </a:p>
@@ -2128,7 +2145,14 @@
           <a:p>
             <a:r>
               <a:rPr lang="en-US" dirty="0"/>
-              <a:t>The one-parent constraint is exactly what Graph of Thoughts removes. It is also why a tree wastes most of what it computes.</a:t>
+              <a:t>SCRIPT  (~45 sec)
+Tree of Thoughts turns reasoning into a search problem. It has three named components: a thought generator that produces k children, a state evaluator that scores them, and a search algorithm - typically breadth-first with a beam - that decides what to expand next. Those map one to one onto operations in our framework.
+What it adds over self-consistency is local exploration. Self-consistency samples k complete chains and picks the best, but the branching happens only at the root - inside any one chain you are still committed. Tree of Thoughts branches at every level and can abandon a bad partial solution part-way.
+Its limitation is structural. Every vertex has exactly one parent, so when the search discards a branch, whatever was good on that branch is lost permanently. There is no operation in a tree that combines two branches. And since only one root-to-leaf path reaches the answer, nearly everything the tree computes is thrown away.
+One note on our own results, because it comes up later: Tree of Thoughts is the strongest baseline we measure - once its evaluator is able to reject a refinement that made the answer worse. We will come back to that clause.
+---
+TRANSITION: Graph of Thoughts removes the one-parent constraint.
+IF ASKED why our ToT is stronger than the paper's: sorting admits an exact scorer, so our state evaluator is never wrong; theirs is typically another LLM call.</a:t>
             </a:r>
             <a:endParaRPr lang="en-US" dirty="0"/>
           </a:p>
@@ -2216,7 +2240,16 @@
           <a:p>
             <a:r>
               <a:rPr lang="en-US" dirty="0"/>
-              <a:t>This is the paper we replicated. The merge steps, in amber, are the operation no tree can express - and also where most of the cost sits.</a:t>
+              <a:t>SCRIPT  (~50 sec)
+Graph of Thoughts models reasoning as a directed graph. Vertices are thoughts, and an edge means one thought's text was the direct input that produced another. So edges encode causality, not similarity - and that definition is what our whole method has to respect.
+The contribution is aggregation: merging k thoughts into one. That creates a vertex with in-degree greater than one, and a tree cannot contain one by definition. So this is a structural result, not a design preference.
+For sorting it runs merge sort with the model as the primitive - split into chunks, sort each chunk, then merge pairwise back up. Sorting sixteen numbers is reliable, and merging two sorted lists is reliable. Sorting sixty-four from scratch is not. So you only ever perform the reliable operations.
+The theoretical result is volume N at latency log N. It is the only scheme where every computed thought keeps a causal path to the answer - a tree discards nearly all of what it computes.
+And the reported gain was sixty-two percent over Tree of Thoughts on ChatGPT-3.5, with a thirty-one percent cost reduction. That is the claim we set out to test.
+---
+TRANSITION: And this is the object we want to compress.
+CUE: point at the amber merge edges when saying 'in-degree greater than one'.
+DO NOT oversell the 62% - we report on slide 11 that it does not reproduce.</a:t>
             </a:r>
             <a:endParaRPr lang="en-US" dirty="0"/>
           </a:p>
@@ -2304,7 +2337,16 @@
           <a:p>
             <a:r>
               <a:rPr lang="en-US" dirty="0"/>
-              <a:t>This is the key literature insight. Chain compression is a large and fast-moving field, but it all shrinks a step. Reducing the number of steps requires structure, which only a graph has.</a:t>
+              <a:t>SCRIPT  (~50 sec)
+The second literature is chain-of-thought compression - a large and very fast-moving field, most of it from the last eighteen months.
+Four representative mechanisms. Chain of Draft caps each reasoning step to a few words and reports getting down to under eight percent of the original tokens with accuracy retained. TokenSkip prunes individual low-utility tokens and gives a controllable ratio. Coconut is the most radical - it feeds the hidden state straight back instead of decoding it, so the reasoning never becomes text at all. And token budgeting allocates an allowance per step by difficulty.
+But notice what they all have in common. Every one of them shortens the CONTENT of a reasoning step. None of them reduces the NUMBER of steps - and they cannot, because a chain has no structure to remove. Every step was generated from the one before it.
+A graph does have removable structure. Graph of Thoughts generates k candidate sortings per chunk and keeps one; it tries k aggregations and keeps one. Those are vertices that exist and do not survive.
+So cost factorises: number of vertices, times tokens per vertex. Chain compression acts on the second factor. Graph coarsening acts on the first. They are orthogonal, so in principle the savings multiply - and that intersection is where this project sits.
+---
+TRANSITION: So our objectives follow from that.
+BE HONEST: orthogonality is an assumption, not a result. It is listed as an open question.
+IF ASKED about Coconut needing training: yes - that row is the most speculative, and a longer-term direction.</a:t>
             </a:r>
             <a:endParaRPr lang="en-US" dirty="0"/>
           </a:p>
@@ -2392,7 +2434,13 @@
           <a:p>
             <a:r>
               <a:rPr lang="en-US" dirty="0"/>
-              <a:t>Four of seven objectives are complete. The remaining three are the contribution itself, and the measurements already made define their target.</a:t>
+              <a:t>SCRIPT  (~45 sec)
+Six objectives. The first three are replication and measurement. Reproduce Graph of Thoughts faithfully with all baselines on a single engine, so that any difference is attributable to structure alone. Verify the structural claims - volume, latency and aggregation count - which are model-independent and therefore settleable outright. And measure where the cost actually accumulates, because you cannot compress what you have not located.
+The last three are the contribution. Apply chain-of-thought compression to the content of each vertex. Develop a causality-preserving coarsening operator to reduce the number of vertices. And evaluate the result against the Tree of Thoughts cost-quality frontier.
+At mid-term the first four items on the right are complete - including a naive-compression study that was not in the original plan, came out of the cost measurement, and became a result in its own right.
+Vertex compression is in progress. The coarsening operator and the final evaluation are ahead of us, and those are the harder half - I would not claim we are past halfway. What the completed work buys us is that we now know precisely what we are aiming at: a specific error at a specific token count.
+---
+IF ASKED whether it is achievable: the infrastructure is done, which was the bulk of the engineering. Vertex compression is measurable this week. The coarsening operator is the research risk, and we have scoped it to two tasks rather than four.</a:t>
             </a:r>
             <a:endParaRPr lang="en-US" dirty="0"/>
           </a:p>
@@ -2480,7 +2528,14 @@
           <a:p>
             <a:r>
               <a:rPr lang="en-US" dirty="0"/>
-              <a:t>Worked example on 32 numbers: the first merge level creates 20 vertices but 40 edges, because each merge draws an edge from both inputs. That fan-in is what a coarsening step has to account for.</a:t>
+              <a:t>SCRIPT  (~60 sec)
+There are two graphs here, and keeping them apart matters. The Graph of Operations is the plan - vertices are operations, and you build it by hand before the run. The Graph Reasoning State is what actually gets produced - vertices are thoughts. Run one plan over a hundred inputs and you get one plan and a hundred state graphs.
+The state graph is built by this single loop, in topological order. Topological is required rather than stylistic: with aggregation the plan is a DAG, so an operation can have two predecessors, and you cannot simply run them in the order they were written.
+The rules are on the right. Generate makes k vertices from one input. Aggregate makes vertices that take an edge from EVERY input - that is the fan-in. Improve refines in place. And Score and KeepBest create nothing at all; they annotate and filter. So only three operations ever create a vertex, which is exactly the paper's three thought transformations.
+The consequence is at the bottom. Aggregation gives a vertex in-degree greater than one, so the graph is not a tree. And an edge means one thought's text was literally the input that produced another - causality, not similarity. That is the constraint our coarsening operator has to respect: we cannot merge two vertices because they look alike.
+---
+SPARE 10 SEC: on 32 numbers the first merge level creates 20 vertices but 40 edges - two per vertex, because each merge draws from both inputs. The only point in the trace where edges outnumber vertices.
+IF ASKED why topological: an operation cannot run before the thoughts it consumes exist, and written order does not guarantee that once the plan is a DAG.</a:t>
             </a:r>
             <a:endParaRPr lang="en-US" dirty="0"/>
           </a:p>
@@ -2568,7 +2623,14 @@
           <a:p>
             <a:r>
               <a:rPr lang="en-US" dirty="0"/>
-              <a:t>The paper's model is deprecated and closed, so exact figures cannot be reproduced. What can be reproduced are the relative claims, and those are what we test.</a:t>
+              <a:t>SCRIPT  (~60 sec)
+All four tasks are synthetic with computed ground truth. That means no annotation - the correct sorting of a list is computable - and crucially no contamination, because randomly generated digits cannot have been in the training data. On a public benchmark you could never separate improved reasoning from memorisation. Difficulty is also a controlled variable: thirty-two, sixty-four, a hundred and twenty-eight.
+And we run on the authors' own published CSV files, byte for byte. That removes differing random data as an explanation for any discrepancy between our numbers and theirs.
+On models. The paper used ChatGPT-3.5, which is closed and now deprecated - nobody can reproduce its exact figures, including the authors. So we do not attempt to replicate the numbers. We replicate the claims, which are relative and testable on any model. We use Qwen2.5-7B, open weights, served with vLLM on an A6000, at identical temperature and sample counts.
+The experimental design is the last line, and it is the one that matters. All five schemes share one controller, one backend, one prompt set and one scorer. So anything we measure is attributable to graph structure alone - not to one scheme happening to have better prompts than another.
+---
+TRANSITION: So - results.
+IF ASKED if 7B is too small: the structural claims are model-independent and settle completely. And whether the quality claim generalises below GPT-3.5 scale is itself a question nobody had tested.</a:t>
             </a:r>
             <a:endParaRPr lang="en-US" dirty="0"/>
           </a:p>
@@ -3113,7 +3175,7 @@
               <a:buNone/>
             </a:pPr>
             <a:r>
-              <a:rPr lang="en-US" sz="850" dirty="0">
+              <a:rPr lang="en-US" sz="1000" dirty="0">
                 <a:solidFill>
                   <a:srgbClr val="63697A"/>
                 </a:solidFill>
@@ -3123,7 +3185,7 @@
               </a:rPr>
               <a:t>Department of Electrical Engineering</a:t>
             </a:r>
-            <a:endParaRPr lang="en-US" sz="850" dirty="0"/>
+            <a:endParaRPr lang="en-US" sz="1000" dirty="0"/>
           </a:p>
         </p:txBody>
       </p:sp>
@@ -3688,7 +3750,7 @@
               <a:buNone/>
             </a:pPr>
             <a:r>
-              <a:rPr lang="en-US" sz="1450" b="1" dirty="0">
+              <a:rPr lang="en-US" sz="1550" b="1" dirty="0">
                 <a:solidFill>
                   <a:srgbClr val="23408E"/>
                 </a:solidFill>
@@ -3698,7 +3760,7 @@
               </a:rPr>
               <a:t>Structural claims - model-independent, and reproduced exactly</a:t>
             </a:r>
-            <a:endParaRPr lang="en-US" sz="1450" dirty="0"/>
+            <a:endParaRPr lang="en-US" sz="1550" dirty="0"/>
           </a:p>
         </p:txBody>
       </p:sp>
@@ -5401,7 +5463,7 @@
           <a:p>
             <a:pPr indent="0" marL="0">
               <a:lnSpc>
-                <a:spcPct val="112000"/>
+                <a:spcPct val="106000"/>
               </a:lnSpc>
               <a:buNone/>
             </a:pPr>
@@ -5472,7 +5534,7 @@
               <a:buNone/>
             </a:pPr>
             <a:r>
-              <a:rPr lang="en-US" sz="1050" b="1" dirty="0">
+              <a:rPr lang="en-US" sz="1300" b="1" dirty="0">
                 <a:solidFill>
                   <a:srgbClr val="0F7B6C"/>
                 </a:solidFill>
@@ -5482,7 +5544,7 @@
               </a:rPr>
               <a:t>Graph of Thoughts is the only scheme that aggregates - measured, not assumed. Every other scheme reports exactly zero.</a:t>
             </a:r>
-            <a:endParaRPr lang="en-US" sz="1050" dirty="0"/>
+            <a:endParaRPr lang="en-US" sz="1300" dirty="0"/>
           </a:p>
         </p:txBody>
       </p:sp>
@@ -5779,7 +5841,7 @@
               <a:buNone/>
             </a:pPr>
             <a:r>
-              <a:rPr lang="en-US" sz="1450" b="1" dirty="0">
+              <a:rPr lang="en-US" sz="1550" b="1" dirty="0">
                 <a:solidFill>
                   <a:srgbClr val="23408E"/>
                 </a:solidFill>
@@ -5789,7 +5851,7 @@
               </a:rPr>
               <a:t>Quality - the paper's claim does not reproduce at 7B</a:t>
             </a:r>
-            <a:endParaRPr lang="en-US" sz="1450" dirty="0"/>
+            <a:endParaRPr lang="en-US" sz="1550" dirty="0"/>
           </a:p>
         </p:txBody>
       </p:sp>
@@ -5832,7 +5894,7 @@
           <a:p>
             <a:pPr indent="0" marL="0">
               <a:lnSpc>
-                <a:spcPct val="112000"/>
+                <a:spcPct val="106000"/>
               </a:lnSpc>
               <a:buNone/>
             </a:pPr>
@@ -5903,7 +5965,7 @@
               <a:buNone/>
             </a:pPr>
             <a:r>
-              <a:rPr lang="en-US" sz="1150" b="1" dirty="0">
+              <a:rPr lang="en-US" sz="1300" b="1" dirty="0">
                 <a:solidFill>
                   <a:srgbClr val="0F7B6C"/>
                 </a:solidFill>
@@ -5913,7 +5975,7 @@
               </a:rPr>
               <a:t>Structure does help</a:t>
             </a:r>
-            <a:endParaRPr lang="en-US" sz="1150" dirty="0"/>
+            <a:endParaRPr lang="en-US" sz="1300" dirty="0"/>
           </a:p>
         </p:txBody>
       </p:sp>
@@ -5942,7 +6004,7 @@
               <a:buNone/>
             </a:pPr>
             <a:r>
-              <a:rPr lang="en-US" sz="1000" dirty="0">
+              <a:rPr lang="en-US" sz="1250" dirty="0">
                 <a:solidFill>
                   <a:srgbClr val="16181D"/>
                 </a:solidFill>
@@ -5952,7 +6014,7 @@
               </a:rPr>
               <a:t>Graph of Thoughts improves on direct prompting by 15.8%, and all structural claims hold exactly.</a:t>
             </a:r>
-            <a:endParaRPr lang="en-US" sz="1000" dirty="0"/>
+            <a:endParaRPr lang="en-US" sz="1250" dirty="0"/>
           </a:p>
         </p:txBody>
       </p:sp>
@@ -6008,7 +6070,7 @@
               <a:buNone/>
             </a:pPr>
             <a:r>
-              <a:rPr lang="en-US" sz="1150" b="1" dirty="0">
+              <a:rPr lang="en-US" sz="1300" b="1" dirty="0">
                 <a:solidFill>
                   <a:srgbClr val="C0392B"/>
                 </a:solidFill>
@@ -6018,7 +6080,7 @@
               </a:rPr>
               <a:t>But Tree of Thoughts wins here</a:t>
             </a:r>
-            <a:endParaRPr lang="en-US" sz="1150" dirty="0"/>
+            <a:endParaRPr lang="en-US" sz="1300" dirty="0"/>
           </a:p>
         </p:txBody>
       </p:sp>
@@ -6047,7 +6109,7 @@
               <a:buNone/>
             </a:pPr>
             <a:r>
-              <a:rPr lang="en-US" sz="1000" dirty="0">
+              <a:rPr lang="en-US" sz="1250" dirty="0">
                 <a:solidFill>
                   <a:srgbClr val="16181D"/>
                 </a:solidFill>
@@ -6057,7 +6119,7 @@
               </a:rPr>
               <a:t>ToT reaches 11.1% lower error than GoT while consuming 3.6x fewer tokens.</a:t>
             </a:r>
-            <a:endParaRPr lang="en-US" sz="1000" dirty="0"/>
+            <a:endParaRPr lang="en-US" sz="1250" dirty="0"/>
           </a:p>
         </p:txBody>
       </p:sp>
@@ -6086,7 +6148,7 @@
               <a:buNone/>
             </a:pPr>
             <a:r>
-              <a:rPr lang="en-US" sz="900" i="1" dirty="0">
+              <a:rPr lang="en-US" sz="1050" i="1" dirty="0">
                 <a:solidFill>
                   <a:srgbClr val="63697A"/>
                 </a:solidFill>
@@ -6096,7 +6158,7 @@
               </a:rPr>
               <a:t>Likely causes: an exact scorer makes ToT's monotone refinement very strong, and at 7B each of GoT's 15 merges is an opportunity to fail.</a:t>
             </a:r>
-            <a:endParaRPr lang="en-US" sz="900" dirty="0"/>
+            <a:endParaRPr lang="en-US" sz="1050" dirty="0"/>
           </a:p>
         </p:txBody>
       </p:sp>
@@ -6152,7 +6214,7 @@
               <a:buNone/>
             </a:pPr>
             <a:r>
-              <a:rPr lang="en-US" sz="1150" b="1" dirty="0">
+              <a:rPr lang="en-US" sz="1300" b="1" dirty="0">
                 <a:solidFill>
                   <a:srgbClr val="23408E"/>
                 </a:solidFill>
@@ -6162,7 +6224,7 @@
               </a:rPr>
               <a:t>A note on baselines</a:t>
             </a:r>
-            <a:endParaRPr lang="en-US" sz="1150" dirty="0"/>
+            <a:endParaRPr lang="en-US" sz="1300" dirty="0"/>
           </a:p>
         </p:txBody>
       </p:sp>
@@ -6191,7 +6253,7 @@
               <a:buNone/>
             </a:pPr>
             <a:r>
-              <a:rPr lang="en-US" sz="900" dirty="0">
+              <a:rPr lang="en-US" sz="1300" dirty="0">
                 <a:solidFill>
                   <a:srgbClr val="16181D"/>
                 </a:solidFill>
@@ -6201,7 +6263,7 @@
               </a:rPr>
               <a:t>An earlier run showed GoT ahead by 17.8%. That margin was an artefact of our own ToT implementation being unable to reject a refinement that worsened the answer. Correcting it reversed the result.</a:t>
             </a:r>
-            <a:endParaRPr lang="en-US" sz="900" dirty="0"/>
+            <a:endParaRPr lang="en-US" sz="1300" dirty="0"/>
           </a:p>
         </p:txBody>
       </p:sp>
@@ -6482,7 +6544,7 @@
               <a:buNone/>
             </a:pPr>
             <a:r>
-              <a:rPr lang="en-US" sz="1450" b="1" dirty="0">
+              <a:rPr lang="en-US" sz="1550" b="1" dirty="0">
                 <a:solidFill>
                   <a:srgbClr val="23408E"/>
                 </a:solidFill>
@@ -6492,7 +6554,7 @@
               </a:rPr>
               <a:t>Cost, and why naive compression fails</a:t>
             </a:r>
-            <a:endParaRPr lang="en-US" sz="1450" dirty="0"/>
+            <a:endParaRPr lang="en-US" sz="1550" dirty="0"/>
           </a:p>
         </p:txBody>
       </p:sp>
@@ -7950,7 +8012,7 @@
               <a:buNone/>
             </a:pPr>
             <a:r>
-              <a:rPr lang="en-US" sz="1050" b="1" dirty="0">
+              <a:rPr lang="en-US" sz="1300" b="1" dirty="0">
                 <a:solidFill>
                   <a:srgbClr val="C0392B"/>
                 </a:solidFill>
@@ -7960,7 +8022,7 @@
               </a:rPr>
               <a:t>Reducing cost ninefold raises the error to 10.50 - worse than using no reasoning structure at all, where direct prompting scores 9.83.</a:t>
             </a:r>
-            <a:endParaRPr lang="en-US" sz="1050" dirty="0"/>
+            <a:endParaRPr lang="en-US" sz="1300" dirty="0"/>
           </a:p>
         </p:txBody>
       </p:sp>
@@ -7987,7 +8049,7 @@
           <a:p>
             <a:pPr indent="0" marL="0">
               <a:lnSpc>
-                <a:spcPct val="112000"/>
+                <a:spcPct val="106000"/>
               </a:lnSpc>
               <a:buNone/>
             </a:pPr>
@@ -8058,7 +8120,7 @@
               <a:buNone/>
             </a:pPr>
             <a:r>
-              <a:rPr lang="en-US" sz="1150" b="1" dirty="0">
+              <a:rPr lang="en-US" sz="1300" b="1" dirty="0">
                 <a:solidFill>
                   <a:srgbClr val="23408E"/>
                 </a:solidFill>
@@ -8068,7 +8130,7 @@
               </a:rPr>
               <a:t>Where the cost accumulates</a:t>
             </a:r>
-            <a:endParaRPr lang="en-US" sz="1150" dirty="0"/>
+            <a:endParaRPr lang="en-US" sz="1300" dirty="0"/>
           </a:p>
         </p:txBody>
       </p:sp>
@@ -8097,7 +8159,7 @@
               <a:buNone/>
             </a:pPr>
             <a:r>
-              <a:rPr lang="en-US" sz="950" dirty="0">
+              <a:rPr lang="en-US" sz="1300" dirty="0">
                 <a:solidFill>
                   <a:srgbClr val="16181D"/>
                 </a:solidFill>
@@ -8107,7 +8169,7 @@
               </a:rPr>
               <a:t>Chunk sorting</a:t>
             </a:r>
-            <a:endParaRPr lang="en-US" sz="950" dirty="0"/>
+            <a:endParaRPr lang="en-US" sz="1300" dirty="0"/>
           </a:p>
         </p:txBody>
       </p:sp>
@@ -8163,7 +8225,7 @@
               <a:buNone/>
             </a:pPr>
             <a:r>
-              <a:rPr lang="en-US" sz="850" dirty="0">
+              <a:rPr lang="en-US" sz="1000" dirty="0">
                 <a:solidFill>
                   <a:srgbClr val="63697A"/>
                 </a:solidFill>
@@ -8173,7 +8235,7 @@
               </a:rPr>
               <a:t>1580</a:t>
             </a:r>
-            <a:endParaRPr lang="en-US" sz="850" dirty="0"/>
+            <a:endParaRPr lang="en-US" sz="1000" dirty="0"/>
           </a:p>
         </p:txBody>
       </p:sp>
@@ -8202,7 +8264,7 @@
               <a:buNone/>
             </a:pPr>
             <a:r>
-              <a:rPr lang="en-US" sz="950" dirty="0">
+              <a:rPr lang="en-US" sz="1300" dirty="0">
                 <a:solidFill>
                   <a:srgbClr val="16181D"/>
                 </a:solidFill>
@@ -8212,7 +8274,7 @@
               </a:rPr>
               <a:t>Merge level 1</a:t>
             </a:r>
-            <a:endParaRPr lang="en-US" sz="950" dirty="0"/>
+            <a:endParaRPr lang="en-US" sz="1300" dirty="0"/>
           </a:p>
         </p:txBody>
       </p:sp>
@@ -8268,7 +8330,7 @@
               <a:buNone/>
             </a:pPr>
             <a:r>
-              <a:rPr lang="en-US" sz="850" dirty="0">
+              <a:rPr lang="en-US" sz="1000" dirty="0">
                 <a:solidFill>
                   <a:srgbClr val="63697A"/>
                 </a:solidFill>
@@ -8278,7 +8340,7 @@
               </a:rPr>
               <a:t>2890</a:t>
             </a:r>
-            <a:endParaRPr lang="en-US" sz="850" dirty="0"/>
+            <a:endParaRPr lang="en-US" sz="1000" dirty="0"/>
           </a:p>
         </p:txBody>
       </p:sp>
@@ -8307,7 +8369,7 @@
               <a:buNone/>
             </a:pPr>
             <a:r>
-              <a:rPr lang="en-US" sz="950" dirty="0">
+              <a:rPr lang="en-US" sz="1300" dirty="0">
                 <a:solidFill>
                   <a:srgbClr val="16181D"/>
                 </a:solidFill>
@@ -8317,7 +8379,7 @@
               </a:rPr>
               <a:t>Merge level 2</a:t>
             </a:r>
-            <a:endParaRPr lang="en-US" sz="950" dirty="0"/>
+            <a:endParaRPr lang="en-US" sz="1300" dirty="0"/>
           </a:p>
         </p:txBody>
       </p:sp>
@@ -8373,7 +8435,7 @@
               <a:buNone/>
             </a:pPr>
             <a:r>
-              <a:rPr lang="en-US" sz="850" dirty="0">
+              <a:rPr lang="en-US" sz="1000" dirty="0">
                 <a:solidFill>
                   <a:srgbClr val="63697A"/>
                 </a:solidFill>
@@ -8383,7 +8445,7 @@
               </a:rPr>
               <a:t>2210</a:t>
             </a:r>
-            <a:endParaRPr lang="en-US" sz="850" dirty="0"/>
+            <a:endParaRPr lang="en-US" sz="1000" dirty="0"/>
           </a:p>
         </p:txBody>
       </p:sp>
@@ -8412,7 +8474,7 @@
               <a:buNone/>
             </a:pPr>
             <a:r>
-              <a:rPr lang="en-US" sz="950" dirty="0">
+              <a:rPr lang="en-US" sz="1300" dirty="0">
                 <a:solidFill>
                   <a:srgbClr val="16181D"/>
                 </a:solidFill>
@@ -8422,7 +8484,7 @@
               </a:rPr>
               <a:t>Final refinement</a:t>
             </a:r>
-            <a:endParaRPr lang="en-US" sz="950" dirty="0"/>
+            <a:endParaRPr lang="en-US" sz="1300" dirty="0"/>
           </a:p>
         </p:txBody>
       </p:sp>
@@ -8478,7 +8540,7 @@
               <a:buNone/>
             </a:pPr>
             <a:r>
-              <a:rPr lang="en-US" sz="850" dirty="0">
+              <a:rPr lang="en-US" sz="1000" dirty="0">
                 <a:solidFill>
                   <a:srgbClr val="63697A"/>
                 </a:solidFill>
@@ -8488,7 +8550,7 @@
               </a:rPr>
               <a:t>1230</a:t>
             </a:r>
-            <a:endParaRPr lang="en-US" sz="850" dirty="0"/>
+            <a:endParaRPr lang="en-US" sz="1000" dirty="0"/>
           </a:p>
         </p:txBody>
       </p:sp>
@@ -8517,7 +8579,7 @@
               <a:buNone/>
             </a:pPr>
             <a:r>
-              <a:rPr lang="en-US" sz="1000" b="1" dirty="0">
+              <a:rPr lang="en-US" sz="1250" b="1" dirty="0">
                 <a:solidFill>
                   <a:srgbClr val="D98A1F"/>
                 </a:solidFill>
@@ -8527,7 +8589,7 @@
               </a:rPr>
               <a:t>Aggregation consumes roughly 65% of the budget - each merge emits a full-length list, and there are fifteen of them.</a:t>
             </a:r>
-            <a:endParaRPr lang="en-US" sz="1000" dirty="0"/>
+            <a:endParaRPr lang="en-US" sz="1250" dirty="0"/>
           </a:p>
         </p:txBody>
       </p:sp>
@@ -8808,7 +8870,7 @@
               <a:buNone/>
             </a:pPr>
             <a:r>
-              <a:rPr lang="en-US" sz="1450" b="1" dirty="0">
+              <a:rPr lang="en-US" sz="1550" b="1" dirty="0">
                 <a:solidFill>
                   <a:srgbClr val="23408E"/>
                 </a:solidFill>
@@ -8818,7 +8880,7 @@
               </a:rPr>
               <a:t>Transferring chain compression to a reasoning graph</a:t>
             </a:r>
-            <a:endParaRPr lang="en-US" sz="1450" dirty="0"/>
+            <a:endParaRPr lang="en-US" sz="1550" dirty="0"/>
           </a:p>
         </p:txBody>
       </p:sp>
@@ -8859,7 +8921,7 @@
                         <a:buNone/>
                       </a:pPr>
                       <a:r>
-                        <a:rPr lang="en-US" sz="950" b="1" dirty="0">
+                        <a:rPr lang="en-US" sz="1150" b="1" dirty="0">
                           <a:solidFill>
                             <a:srgbClr val="FFFFFF"/>
                           </a:solidFill>
@@ -8869,7 +8931,7 @@
                         </a:rPr>
                         <a:t>Chain technique</a:t>
                       </a:r>
-                      <a:endParaRPr lang="en-US" sz="950" dirty="0">
+                      <a:endParaRPr lang="en-US" sz="1150" dirty="0">
                         <a:latin typeface="Montserrat" charset="0"/>
                         <a:ea typeface="Montserrat" charset="0"/>
                         <a:cs typeface="Montserrat" charset="0"/>
@@ -8927,7 +8989,7 @@
                         <a:buNone/>
                       </a:pPr>
                       <a:r>
-                        <a:rPr lang="en-US" sz="950" b="1" dirty="0">
+                        <a:rPr lang="en-US" sz="1150" b="1" dirty="0">
                           <a:solidFill>
                             <a:srgbClr val="FFFFFF"/>
                           </a:solidFill>
@@ -8937,7 +8999,7 @@
                         </a:rPr>
                         <a:t>Graph analogue we propose</a:t>
                       </a:r>
-                      <a:endParaRPr lang="en-US" sz="950" dirty="0">
+                      <a:endParaRPr lang="en-US" sz="1150" dirty="0">
                         <a:latin typeface="Montserrat" charset="0"/>
                         <a:ea typeface="Montserrat" charset="0"/>
                         <a:cs typeface="Montserrat" charset="0"/>
@@ -8995,7 +9057,7 @@
                         <a:buNone/>
                       </a:pPr>
                       <a:r>
-                        <a:rPr lang="en-US" sz="950" b="1" dirty="0">
+                        <a:rPr lang="en-US" sz="1150" b="1" dirty="0">
                           <a:solidFill>
                             <a:srgbClr val="FFFFFF"/>
                           </a:solidFill>
@@ -9005,7 +9067,7 @@
                         </a:rPr>
                         <a:t>Expected effect</a:t>
                       </a:r>
-                      <a:endParaRPr lang="en-US" sz="950" dirty="0">
+                      <a:endParaRPr lang="en-US" sz="1150" dirty="0">
                         <a:latin typeface="Montserrat" charset="0"/>
                         <a:ea typeface="Montserrat" charset="0"/>
                         <a:cs typeface="Montserrat" charset="0"/>
@@ -9065,7 +9127,7 @@
                         <a:buNone/>
                       </a:pPr>
                       <a:r>
-                        <a:rPr lang="en-US" sz="950" b="1" dirty="0">
+                        <a:rPr lang="en-US" sz="1150" b="1" dirty="0">
                           <a:solidFill>
                             <a:srgbClr val="16181D"/>
                           </a:solidFill>
@@ -9075,7 +9137,7 @@
                         </a:rPr>
                         <a:t>Chain of Draft</a:t>
                       </a:r>
-                      <a:endParaRPr lang="en-US" sz="950" dirty="0">
+                      <a:endParaRPr lang="en-US" sz="1150" dirty="0">
                         <a:latin typeface="Montserrat" charset="0"/>
                         <a:ea typeface="Montserrat" charset="0"/>
                         <a:cs typeface="Montserrat" charset="0"/>
@@ -9133,7 +9195,7 @@
                         <a:buNone/>
                       </a:pPr>
                       <a:r>
-                        <a:rPr lang="en-US" sz="950" dirty="0">
+                        <a:rPr lang="en-US" sz="1150" dirty="0">
                           <a:solidFill>
                             <a:srgbClr val="16181D"/>
                           </a:solidFill>
@@ -9143,7 +9205,7 @@
                         </a:rPr>
                         <a:t>Encode each vertex compactly - a sorted chunk as run-length pairs rather than a literal list</a:t>
                       </a:r>
-                      <a:endParaRPr lang="en-US" sz="950" dirty="0">
+                      <a:endParaRPr lang="en-US" sz="1150" dirty="0">
                         <a:latin typeface="Montserrat" charset="0"/>
                         <a:ea typeface="Montserrat" charset="0"/>
                         <a:cs typeface="Montserrat" charset="0"/>
@@ -9201,7 +9263,7 @@
                         <a:buNone/>
                       </a:pPr>
                       <a:r>
-                        <a:rPr lang="en-US" sz="950" dirty="0">
+                        <a:rPr lang="en-US" sz="1150" dirty="0">
                           <a:solidFill>
                             <a:srgbClr val="16181D"/>
                           </a:solidFill>
@@ -9211,7 +9273,7 @@
                         </a:rPr>
                         <a:t>Lossless here; 3.8x fewer tokens per vertex (measured)</a:t>
                       </a:r>
-                      <a:endParaRPr lang="en-US" sz="950" dirty="0">
+                      <a:endParaRPr lang="en-US" sz="1150" dirty="0">
                         <a:latin typeface="Montserrat" charset="0"/>
                         <a:ea typeface="Montserrat" charset="0"/>
                         <a:cs typeface="Montserrat" charset="0"/>
@@ -9271,7 +9333,7 @@
                         <a:buNone/>
                       </a:pPr>
                       <a:r>
-                        <a:rPr lang="en-US" sz="950" b="1" dirty="0">
+                        <a:rPr lang="en-US" sz="1150" b="1" dirty="0">
                           <a:solidFill>
                             <a:srgbClr val="16181D"/>
                           </a:solidFill>
@@ -9281,7 +9343,7 @@
                         </a:rPr>
                         <a:t>TokenSkip</a:t>
                       </a:r>
-                      <a:endParaRPr lang="en-US" sz="950" dirty="0">
+                      <a:endParaRPr lang="en-US" sz="1150" dirty="0">
                         <a:latin typeface="Montserrat" charset="0"/>
                         <a:ea typeface="Montserrat" charset="0"/>
                         <a:cs typeface="Montserrat" charset="0"/>
@@ -9339,7 +9401,7 @@
                         <a:buNone/>
                       </a:pPr>
                       <a:r>
-                        <a:rPr lang="en-US" sz="950" dirty="0">
+                        <a:rPr lang="en-US" sz="1150" dirty="0">
                           <a:solidFill>
                             <a:srgbClr val="16181D"/>
                           </a:solidFill>
@@ -9349,7 +9411,7 @@
                         </a:rPr>
                         <a:t>Ablate each vertex; drop those whose removal does not change the answer</a:t>
                       </a:r>
-                      <a:endParaRPr lang="en-US" sz="950" dirty="0">
+                      <a:endParaRPr lang="en-US" sz="1150" dirty="0">
                         <a:latin typeface="Montserrat" charset="0"/>
                         <a:ea typeface="Montserrat" charset="0"/>
                         <a:cs typeface="Montserrat" charset="0"/>
@@ -9407,7 +9469,7 @@
                         <a:buNone/>
                       </a:pPr>
                       <a:r>
-                        <a:rPr lang="en-US" sz="950" dirty="0">
+                        <a:rPr lang="en-US" sz="1150" dirty="0">
                           <a:solidFill>
                             <a:srgbClr val="16181D"/>
                           </a:solidFill>
@@ -9417,7 +9479,7 @@
                         </a:rPr>
                         <a:t>Reduces |V| directly</a:t>
                       </a:r>
-                      <a:endParaRPr lang="en-US" sz="950" dirty="0">
+                      <a:endParaRPr lang="en-US" sz="1150" dirty="0">
                         <a:latin typeface="Montserrat" charset="0"/>
                         <a:ea typeface="Montserrat" charset="0"/>
                         <a:cs typeface="Montserrat" charset="0"/>
@@ -9477,7 +9539,7 @@
                         <a:buNone/>
                       </a:pPr>
                       <a:r>
-                        <a:rPr lang="en-US" sz="950" b="1" dirty="0">
+                        <a:rPr lang="en-US" sz="1150" b="1" dirty="0">
                           <a:solidFill>
                             <a:srgbClr val="16181D"/>
                           </a:solidFill>
@@ -9487,7 +9549,7 @@
                         </a:rPr>
                         <a:t>Coconut</a:t>
                       </a:r>
-                      <a:endParaRPr lang="en-US" sz="950" dirty="0">
+                      <a:endParaRPr lang="en-US" sz="1150" dirty="0">
                         <a:latin typeface="Montserrat" charset="0"/>
                         <a:ea typeface="Montserrat" charset="0"/>
                         <a:cs typeface="Montserrat" charset="0"/>
@@ -9545,7 +9607,7 @@
                         <a:buNone/>
                       </a:pPr>
                       <a:r>
-                        <a:rPr lang="en-US" sz="950" dirty="0">
+                        <a:rPr lang="en-US" sz="1150" dirty="0">
                           <a:solidFill>
                             <a:srgbClr val="16181D"/>
                           </a:solidFill>
@@ -9555,7 +9617,7 @@
                         </a:rPr>
                         <a:t>Aggregate in latent space - merge hidden states without decoding to text</a:t>
                       </a:r>
-                      <a:endParaRPr lang="en-US" sz="950" dirty="0">
+                      <a:endParaRPr lang="en-US" sz="1150" dirty="0">
                         <a:latin typeface="Montserrat" charset="0"/>
                         <a:ea typeface="Montserrat" charset="0"/>
                         <a:cs typeface="Montserrat" charset="0"/>
@@ -9613,7 +9675,7 @@
                         <a:buNone/>
                       </a:pPr>
                       <a:r>
-                        <a:rPr lang="en-US" sz="950" dirty="0">
+                        <a:rPr lang="en-US" sz="1150" dirty="0">
                           <a:solidFill>
                             <a:srgbClr val="16181D"/>
                           </a:solidFill>
@@ -9623,7 +9685,7 @@
                         </a:rPr>
                         <a:t>Removes decode cost at the 15 merge steps</a:t>
                       </a:r>
-                      <a:endParaRPr lang="en-US" sz="950" dirty="0">
+                      <a:endParaRPr lang="en-US" sz="1150" dirty="0">
                         <a:latin typeface="Montserrat" charset="0"/>
                         <a:ea typeface="Montserrat" charset="0"/>
                         <a:cs typeface="Montserrat" charset="0"/>
@@ -9683,7 +9745,7 @@
                         <a:buNone/>
                       </a:pPr>
                       <a:r>
-                        <a:rPr lang="en-US" sz="950" b="1" dirty="0">
+                        <a:rPr lang="en-US" sz="1150" b="1" dirty="0">
                           <a:solidFill>
                             <a:srgbClr val="16181D"/>
                           </a:solidFill>
@@ -9693,7 +9755,7 @@
                         </a:rPr>
                         <a:t>Token budgeting</a:t>
                       </a:r>
-                      <a:endParaRPr lang="en-US" sz="950" dirty="0">
+                      <a:endParaRPr lang="en-US" sz="1150" dirty="0">
                         <a:latin typeface="Montserrat" charset="0"/>
                         <a:ea typeface="Montserrat" charset="0"/>
                         <a:cs typeface="Montserrat" charset="0"/>
@@ -9751,7 +9813,7 @@
                         <a:buNone/>
                       </a:pPr>
                       <a:r>
-                        <a:rPr lang="en-US" sz="950" dirty="0">
+                        <a:rPr lang="en-US" sz="1150" dirty="0">
                           <a:solidFill>
                             <a:srgbClr val="16181D"/>
                           </a:solidFill>
@@ -9761,7 +9823,7 @@
                         </a:rPr>
                         <a:t>Allocate k per vertex by measured difficulty rather than uniformly</a:t>
                       </a:r>
-                      <a:endParaRPr lang="en-US" sz="950" dirty="0">
+                      <a:endParaRPr lang="en-US" sz="1150" dirty="0">
                         <a:latin typeface="Montserrat" charset="0"/>
                         <a:ea typeface="Montserrat" charset="0"/>
                         <a:cs typeface="Montserrat" charset="0"/>
@@ -9819,7 +9881,7 @@
                         <a:buNone/>
                       </a:pPr>
                       <a:r>
-                        <a:rPr lang="en-US" sz="950" dirty="0">
+                        <a:rPr lang="en-US" sz="1150" dirty="0">
                           <a:solidFill>
                             <a:srgbClr val="16181D"/>
                           </a:solidFill>
@@ -9829,7 +9891,7 @@
                         </a:rPr>
                         <a:t>Spend where errors concentrate</a:t>
                       </a:r>
-                      <a:endParaRPr lang="en-US" sz="950" dirty="0">
+                      <a:endParaRPr lang="en-US" sz="1150" dirty="0">
                         <a:latin typeface="Montserrat" charset="0"/>
                         <a:ea typeface="Montserrat" charset="0"/>
                         <a:cs typeface="Montserrat" charset="0"/>
@@ -10001,7 +10063,7 @@
               <a:buNone/>
             </a:pPr>
             <a:r>
-              <a:rPr lang="en-US" sz="1150" b="1" dirty="0">
+              <a:rPr lang="en-US" sz="1300" b="1" dirty="0">
                 <a:solidFill>
                   <a:srgbClr val="23408E"/>
                 </a:solidFill>
@@ -10011,7 +10073,7 @@
               </a:rPr>
               <a:t>Pipeline</a:t>
             </a:r>
-            <a:endParaRPr lang="en-US" sz="1150" dirty="0"/>
+            <a:endParaRPr lang="en-US" sz="1300" dirty="0"/>
           </a:p>
         </p:txBody>
       </p:sp>
@@ -10065,7 +10127,7 @@
               <a:buNone/>
             </a:pPr>
             <a:r>
-              <a:rPr lang="en-US" sz="950" b="1" dirty="0">
+              <a:rPr lang="en-US" sz="1050" b="1" dirty="0">
                 <a:solidFill>
                   <a:srgbClr val="FFFFFF"/>
                 </a:solidFill>
@@ -10075,7 +10137,7 @@
               </a:rPr>
               <a:t>1</a:t>
             </a:r>
-            <a:endParaRPr lang="en-US" sz="950" dirty="0"/>
+            <a:endParaRPr lang="en-US" sz="1050" dirty="0"/>
           </a:p>
         </p:txBody>
       </p:sp>
@@ -10104,7 +10166,7 @@
               <a:buNone/>
             </a:pPr>
             <a:r>
-              <a:rPr lang="en-US" sz="900" dirty="0">
+              <a:rPr lang="en-US" sz="1300" dirty="0">
                 <a:solidFill>
                   <a:srgbClr val="16181D"/>
                 </a:solidFill>
@@ -10114,7 +10176,7 @@
               </a:rPr>
               <a:t>Instrument: per-vertex token cost and marginal contribution</a:t>
             </a:r>
-            <a:endParaRPr lang="en-US" sz="900" dirty="0"/>
+            <a:endParaRPr lang="en-US" sz="1300" dirty="0"/>
           </a:p>
         </p:txBody>
       </p:sp>
@@ -10168,7 +10230,7 @@
               <a:buNone/>
             </a:pPr>
             <a:r>
-              <a:rPr lang="en-US" sz="950" b="1" dirty="0">
+              <a:rPr lang="en-US" sz="1050" b="1" dirty="0">
                 <a:solidFill>
                   <a:srgbClr val="FFFFFF"/>
                 </a:solidFill>
@@ -10178,7 +10240,7 @@
               </a:rPr>
               <a:t>2</a:t>
             </a:r>
-            <a:endParaRPr lang="en-US" sz="950" dirty="0"/>
+            <a:endParaRPr lang="en-US" sz="1050" dirty="0"/>
           </a:p>
         </p:txBody>
       </p:sp>
@@ -10207,7 +10269,7 @@
               <a:buNone/>
             </a:pPr>
             <a:r>
-              <a:rPr lang="en-US" sz="900" dirty="0">
+              <a:rPr lang="en-US" sz="1300" dirty="0">
                 <a:solidFill>
                   <a:srgbClr val="16181D"/>
                 </a:solidFill>
@@ -10217,7 +10279,7 @@
               </a:rPr>
               <a:t>Compress vertex content with a compact encoding</a:t>
             </a:r>
-            <a:endParaRPr lang="en-US" sz="900" dirty="0"/>
+            <a:endParaRPr lang="en-US" sz="1300" dirty="0"/>
           </a:p>
         </p:txBody>
       </p:sp>
@@ -10271,7 +10333,7 @@
               <a:buNone/>
             </a:pPr>
             <a:r>
-              <a:rPr lang="en-US" sz="950" b="1" dirty="0">
+              <a:rPr lang="en-US" sz="1050" b="1" dirty="0">
                 <a:solidFill>
                   <a:srgbClr val="FFFFFF"/>
                 </a:solidFill>
@@ -10281,7 +10343,7 @@
               </a:rPr>
               <a:t>3</a:t>
             </a:r>
-            <a:endParaRPr lang="en-US" sz="950" dirty="0"/>
+            <a:endParaRPr lang="en-US" sz="1050" dirty="0"/>
           </a:p>
         </p:txBody>
       </p:sp>
@@ -10310,7 +10372,7 @@
               <a:buNone/>
             </a:pPr>
             <a:r>
-              <a:rPr lang="en-US" sz="900" dirty="0">
+              <a:rPr lang="en-US" sz="1300" dirty="0">
                 <a:solidFill>
                   <a:srgbClr val="16181D"/>
                 </a:solidFill>
@@ -10320,7 +10382,7 @@
               </a:rPr>
               <a:t>Coarsen: merge or drop low-contribution vertices</a:t>
             </a:r>
-            <a:endParaRPr lang="en-US" sz="900" dirty="0"/>
+            <a:endParaRPr lang="en-US" sz="1300" dirty="0"/>
           </a:p>
         </p:txBody>
       </p:sp>
@@ -10374,7 +10436,7 @@
               <a:buNone/>
             </a:pPr>
             <a:r>
-              <a:rPr lang="en-US" sz="950" b="1" dirty="0">
+              <a:rPr lang="en-US" sz="1050" b="1" dirty="0">
                 <a:solidFill>
                   <a:srgbClr val="FFFFFF"/>
                 </a:solidFill>
@@ -10384,7 +10446,7 @@
               </a:rPr>
               <a:t>4</a:t>
             </a:r>
-            <a:endParaRPr lang="en-US" sz="950" dirty="0"/>
+            <a:endParaRPr lang="en-US" sz="1050" dirty="0"/>
           </a:p>
         </p:txBody>
       </p:sp>
@@ -10413,7 +10475,7 @@
               <a:buNone/>
             </a:pPr>
             <a:r>
-              <a:rPr lang="en-US" sz="900" dirty="0">
+              <a:rPr lang="en-US" sz="1300" dirty="0">
                 <a:solidFill>
                   <a:srgbClr val="16181D"/>
                 </a:solidFill>
@@ -10423,7 +10485,7 @@
               </a:rPr>
               <a:t>Verify reachability to the final thought is preserved</a:t>
             </a:r>
-            <a:endParaRPr lang="en-US" sz="900" dirty="0"/>
+            <a:endParaRPr lang="en-US" sz="1300" dirty="0"/>
           </a:p>
         </p:txBody>
       </p:sp>
@@ -10477,7 +10539,7 @@
               <a:buNone/>
             </a:pPr>
             <a:r>
-              <a:rPr lang="en-US" sz="950" b="1" dirty="0">
+              <a:rPr lang="en-US" sz="1050" b="1" dirty="0">
                 <a:solidFill>
                   <a:srgbClr val="FFFFFF"/>
                 </a:solidFill>
@@ -10487,7 +10549,7 @@
               </a:rPr>
               <a:t>5</a:t>
             </a:r>
-            <a:endParaRPr lang="en-US" sz="950" dirty="0"/>
+            <a:endParaRPr lang="en-US" sz="1050" dirty="0"/>
           </a:p>
         </p:txBody>
       </p:sp>
@@ -10516,7 +10578,7 @@
               <a:buNone/>
             </a:pPr>
             <a:r>
-              <a:rPr lang="en-US" sz="900" dirty="0">
+              <a:rPr lang="en-US" sz="1300" dirty="0">
                 <a:solidFill>
                   <a:srgbClr val="16181D"/>
                 </a:solidFill>
@@ -10526,7 +10588,7 @@
               </a:rPr>
               <a:t>Evaluate against the ToT cost-quality frontier</a:t>
             </a:r>
-            <a:endParaRPr lang="en-US" sz="900" dirty="0"/>
+            <a:endParaRPr lang="en-US" sz="1300" dirty="0"/>
           </a:p>
         </p:txBody>
       </p:sp>
@@ -10582,7 +10644,7 @@
               <a:buNone/>
             </a:pPr>
             <a:r>
-              <a:rPr lang="en-US" sz="1050" b="1" dirty="0">
+              <a:rPr lang="en-US" sz="1300" b="1" dirty="0">
                 <a:solidFill>
                   <a:srgbClr val="0F7B6C"/>
                 </a:solidFill>
@@ -10592,7 +10654,7 @@
               </a:rPr>
               <a:t>Target, set by our own measurement:  reach error 7.45 at 2,185 tokens - where Tree of Thoughts sits today. Graph of Thoughts is currently at 8.28 error and 7,910 tokens.</a:t>
             </a:r>
-            <a:endParaRPr lang="en-US" sz="1050" dirty="0"/>
+            <a:endParaRPr lang="en-US" sz="1300" dirty="0"/>
           </a:p>
         </p:txBody>
       </p:sp>
@@ -10869,18 +10931,18 @@
           <a:bodyPr wrap="square" lIns="0" tIns="0" rIns="0" bIns="0" rtlCol="0" anchor="ctr"/>
           <a:lstStyle/>
           <a:p>
-            <a:pPr marL="342900" indent="-342900">
+            <a:pPr marL="127000" indent="-127000">
               <a:lnSpc>
-                <a:spcPct val="110000"/>
+                <a:spcPct val="104000"/>
               </a:lnSpc>
               <a:spcAft>
-                <a:spcPts val="700"/>
+                <a:spcPts val="400"/>
               </a:spcAft>
               <a:buSzPct val="100000"/>
               <a:buChar char="•"/>
             </a:pPr>
             <a:r>
-              <a:rPr lang="en-US" sz="1250" dirty="0">
+              <a:rPr lang="en-US" sz="1400" dirty="0">
                 <a:solidFill>
                   <a:srgbClr val="16181D"/>
                 </a:solidFill>
@@ -10890,21 +10952,21 @@
               </a:rPr>
               <a:t>Complete the sweeps now running - aggregation attempts and chunk count across 32, 64 and 128 elements</a:t>
             </a:r>
-            <a:endParaRPr lang="en-US" sz="1250" dirty="0"/>
+            <a:endParaRPr lang="en-US" sz="1400" dirty="0"/>
           </a:p>
           <a:p>
-            <a:pPr marL="342900" indent="-342900">
+            <a:pPr marL="127000" indent="-127000">
               <a:lnSpc>
-                <a:spcPct val="110000"/>
+                <a:spcPct val="104000"/>
               </a:lnSpc>
               <a:spcAft>
-                <a:spcPts val="700"/>
+                <a:spcPts val="400"/>
               </a:spcAft>
               <a:buSzPct val="100000"/>
               <a:buChar char="•"/>
             </a:pPr>
             <a:r>
-              <a:rPr lang="en-US" sz="1250" dirty="0">
+              <a:rPr lang="en-US" sz="1400" dirty="0">
                 <a:solidFill>
                   <a:srgbClr val="16181D"/>
                 </a:solidFill>
@@ -10914,21 +10976,21 @@
               </a:rPr>
               <a:t>Implement compact vertex encoding and measure its accuracy cost</a:t>
             </a:r>
-            <a:endParaRPr lang="en-US" sz="1250" dirty="0"/>
+            <a:endParaRPr lang="en-US" sz="1400" dirty="0"/>
           </a:p>
           <a:p>
-            <a:pPr marL="342900" indent="-342900">
+            <a:pPr marL="127000" indent="-127000">
               <a:lnSpc>
-                <a:spcPct val="110000"/>
+                <a:spcPct val="104000"/>
               </a:lnSpc>
               <a:spcAft>
-                <a:spcPts val="700"/>
+                <a:spcPts val="400"/>
               </a:spcAft>
               <a:buSzPct val="100000"/>
               <a:buChar char="•"/>
             </a:pPr>
             <a:r>
-              <a:rPr lang="en-US" sz="1250" dirty="0">
+              <a:rPr lang="en-US" sz="1400" dirty="0">
                 <a:solidFill>
                   <a:srgbClr val="16181D"/>
                 </a:solidFill>
@@ -10938,21 +11000,21 @@
               </a:rPr>
               <a:t>Define the coarsening operator formally, with reachability to the final thought as the preserved invariant</a:t>
             </a:r>
-            <a:endParaRPr lang="en-US" sz="1250" dirty="0"/>
+            <a:endParaRPr lang="en-US" sz="1400" dirty="0"/>
           </a:p>
           <a:p>
-            <a:pPr marL="342900" indent="-342900">
+            <a:pPr marL="127000" indent="-127000">
               <a:lnSpc>
-                <a:spcPct val="110000"/>
+                <a:spcPct val="104000"/>
               </a:lnSpc>
               <a:spcAft>
-                <a:spcPts val="700"/>
+                <a:spcPts val="400"/>
               </a:spcAft>
               <a:buSzPct val="100000"/>
               <a:buChar char="•"/>
             </a:pPr>
             <a:r>
-              <a:rPr lang="en-US" sz="1250" dirty="0">
+              <a:rPr lang="en-US" sz="1400" dirty="0">
                 <a:solidFill>
                   <a:srgbClr val="16181D"/>
                 </a:solidFill>
@@ -10962,21 +11024,21 @@
               </a:rPr>
               <a:t>Establish whether coarsening and vertex compression compose as predicted, or interact</a:t>
             </a:r>
-            <a:endParaRPr lang="en-US" sz="1250" dirty="0"/>
+            <a:endParaRPr lang="en-US" sz="1400" dirty="0"/>
           </a:p>
           <a:p>
-            <a:pPr marL="342900" indent="-342900">
+            <a:pPr marL="127000" indent="-127000">
               <a:lnSpc>
-                <a:spcPct val="110000"/>
+                <a:spcPct val="104000"/>
               </a:lnSpc>
               <a:spcAft>
-                <a:spcPts val="700"/>
+                <a:spcPts val="400"/>
               </a:spcAft>
               <a:buSzPct val="100000"/>
               <a:buChar char="•"/>
             </a:pPr>
             <a:r>
-              <a:rPr lang="en-US" sz="1250" dirty="0">
+              <a:rPr lang="en-US" sz="1400" dirty="0">
                 <a:solidFill>
                   <a:srgbClr val="16181D"/>
                 </a:solidFill>
@@ -10986,21 +11048,21 @@
               </a:rPr>
               <a:t>Repeat at a larger model scale, to separate scale effects from structural ones</a:t>
             </a:r>
-            <a:endParaRPr lang="en-US" sz="1250" dirty="0"/>
+            <a:endParaRPr lang="en-US" sz="1400" dirty="0"/>
           </a:p>
           <a:p>
-            <a:pPr marL="342900" indent="-342900">
+            <a:pPr marL="127000" indent="-127000">
               <a:lnSpc>
-                <a:spcPct val="110000"/>
+                <a:spcPct val="104000"/>
               </a:lnSpc>
               <a:spcAft>
-                <a:spcPts val="700"/>
+                <a:spcPts val="400"/>
               </a:spcAft>
               <a:buSzPct val="100000"/>
               <a:buChar char="•"/>
             </a:pPr>
             <a:r>
-              <a:rPr lang="en-US" sz="1250" dirty="0">
+              <a:rPr lang="en-US" sz="1400" dirty="0">
                 <a:solidFill>
                   <a:srgbClr val="16181D"/>
                 </a:solidFill>
@@ -11010,7 +11072,7 @@
               </a:rPr>
               <a:t>Extend beyond sorting to set intersection, where aggregation is a union rather than a merge</a:t>
             </a:r>
-            <a:endParaRPr lang="en-US" sz="1250" dirty="0"/>
+            <a:endParaRPr lang="en-US" sz="1400" dirty="0"/>
           </a:p>
         </p:txBody>
       </p:sp>
@@ -11066,7 +11128,7 @@
               <a:buNone/>
             </a:pPr>
             <a:r>
-              <a:rPr lang="en-US" sz="1150" b="1" dirty="0">
+              <a:rPr lang="en-US" sz="1300" b="1" dirty="0">
                 <a:solidFill>
                   <a:srgbClr val="23408E"/>
                 </a:solidFill>
@@ -11076,7 +11138,7 @@
               </a:rPr>
               <a:t>Open questions</a:t>
             </a:r>
-            <a:endParaRPr lang="en-US" sz="1150" dirty="0"/>
+            <a:endParaRPr lang="en-US" sz="1300" dirty="0"/>
           </a:p>
         </p:txBody>
       </p:sp>
@@ -11144,7 +11206,7 @@
               <a:buNone/>
             </a:pPr>
             <a:r>
-              <a:rPr lang="en-US" sz="950" dirty="0">
+              <a:rPr lang="en-US" sz="1300" dirty="0">
                 <a:solidFill>
                   <a:srgbClr val="16181D"/>
                 </a:solidFill>
@@ -11154,7 +11216,7 @@
               </a:rPr>
               <a:t>Does latent aggregation preserve causality in any meaningful sense, or dissolve the edge semantics entirely?</a:t>
             </a:r>
-            <a:endParaRPr lang="en-US" sz="950" dirty="0"/>
+            <a:endParaRPr lang="en-US" sz="1300" dirty="0"/>
           </a:p>
         </p:txBody>
       </p:sp>
@@ -11222,7 +11284,7 @@
               <a:buNone/>
             </a:pPr>
             <a:r>
-              <a:rPr lang="en-US" sz="950" dirty="0">
+              <a:rPr lang="en-US" sz="1300" dirty="0">
                 <a:solidFill>
                   <a:srgbClr val="16181D"/>
                 </a:solidFill>
@@ -11232,7 +11294,7 @@
               </a:rPr>
               <a:t>Is there a principled criterion for vertex removal, or must it be learned per task?</a:t>
             </a:r>
-            <a:endParaRPr lang="en-US" sz="950" dirty="0"/>
+            <a:endParaRPr lang="en-US" sz="1300" dirty="0"/>
           </a:p>
         </p:txBody>
       </p:sp>
@@ -11300,7 +11362,7 @@
               <a:buNone/>
             </a:pPr>
             <a:r>
-              <a:rPr lang="en-US" sz="950" dirty="0">
+              <a:rPr lang="en-US" sz="1300" dirty="0">
                 <a:solidFill>
                   <a:srgbClr val="16181D"/>
                 </a:solidFill>
@@ -11310,7 +11372,7 @@
               </a:rPr>
               <a:t>Does GoT's disadvantage at 7B close with scale, or is aggregation intrinsically fragile?</a:t>
             </a:r>
-            <a:endParaRPr lang="en-US" sz="950" dirty="0"/>
+            <a:endParaRPr lang="en-US" sz="1300" dirty="0"/>
           </a:p>
         </p:txBody>
       </p:sp>
@@ -11594,7 +11656,7 @@
               <a:buNone/>
             </a:pPr>
             <a:r>
-              <a:rPr lang="en-US" sz="900" dirty="0">
+              <a:rPr lang="en-US" sz="1300" dirty="0">
                 <a:solidFill>
                   <a:srgbClr val="16181D"/>
                 </a:solidFill>
@@ -11604,7 +11666,7 @@
               </a:rPr>
               <a:t>[1] M. Besta, N. Blach, A. Kubicek, et al., "Graph of Thoughts: Solving elaborate problems with large language models," in Proc. AAAI Conf. Artif. Intell., vol. 38, 2024, arXiv:2308.09687.</a:t>
             </a:r>
-            <a:endParaRPr lang="en-US" sz="900" dirty="0"/>
+            <a:endParaRPr lang="en-US" sz="1300" dirty="0"/>
           </a:p>
         </p:txBody>
       </p:sp>
@@ -11636,7 +11698,7 @@
               <a:buNone/>
             </a:pPr>
             <a:r>
-              <a:rPr lang="en-US" sz="900" dirty="0">
+              <a:rPr lang="en-US" sz="1300" dirty="0">
                 <a:solidFill>
                   <a:srgbClr val="16181D"/>
                 </a:solidFill>
@@ -11646,7 +11708,7 @@
               </a:rPr>
               <a:t>[2] S. Yao, D. Yu, J. Zhao, et al., "Tree of Thoughts: Deliberate problem solving with large language models," in Adv. Neural Inf. Process. Syst. (NeurIPS), 2023, arXiv:2305.10601.</a:t>
             </a:r>
-            <a:endParaRPr lang="en-US" sz="900" dirty="0"/>
+            <a:endParaRPr lang="en-US" sz="1300" dirty="0"/>
           </a:p>
         </p:txBody>
       </p:sp>
@@ -11678,7 +11740,7 @@
               <a:buNone/>
             </a:pPr>
             <a:r>
-              <a:rPr lang="en-US" sz="900" dirty="0">
+              <a:rPr lang="en-US" sz="1300" dirty="0">
                 <a:solidFill>
                   <a:srgbClr val="16181D"/>
                 </a:solidFill>
@@ -11688,7 +11750,7 @@
               </a:rPr>
               <a:t>[3] J. Wei, X. Wang, D. Schuurmans, et al., "Chain-of-thought prompting elicits reasoning in large language models," in Adv. Neural Inf. Process. Syst. (NeurIPS), 2022, arXiv:2201.11903.</a:t>
             </a:r>
-            <a:endParaRPr lang="en-US" sz="900" dirty="0"/>
+            <a:endParaRPr lang="en-US" sz="1300" dirty="0"/>
           </a:p>
         </p:txBody>
       </p:sp>
@@ -11720,7 +11782,7 @@
               <a:buNone/>
             </a:pPr>
             <a:r>
-              <a:rPr lang="en-US" sz="900" dirty="0">
+              <a:rPr lang="en-US" sz="1300" dirty="0">
                 <a:solidFill>
                   <a:srgbClr val="16181D"/>
                 </a:solidFill>
@@ -11730,7 +11792,7 @@
               </a:rPr>
               <a:t>[4] X. Wang, J. Wei, D. Schuurmans, et al., "Self-consistency improves chain of thought reasoning in language models," in Proc. Int. Conf. Learn. Represent. (ICLR), 2023, arXiv:2203.11171.</a:t>
             </a:r>
-            <a:endParaRPr lang="en-US" sz="900" dirty="0"/>
+            <a:endParaRPr lang="en-US" sz="1300" dirty="0"/>
           </a:p>
         </p:txBody>
       </p:sp>
@@ -11762,7 +11824,7 @@
               <a:buNone/>
             </a:pPr>
             <a:r>
-              <a:rPr lang="en-US" sz="900" dirty="0">
+              <a:rPr lang="en-US" sz="1300" dirty="0">
                 <a:solidFill>
                   <a:srgbClr val="16181D"/>
                 </a:solidFill>
@@ -11772,7 +11834,7 @@
               </a:rPr>
               <a:t>[5] S. Xu, W. Xie, L. Zhao, and P. He, "Chain of Draft: Thinking faster by writing less," 2025, arXiv:2502.18600.</a:t>
             </a:r>
-            <a:endParaRPr lang="en-US" sz="900" dirty="0"/>
+            <a:endParaRPr lang="en-US" sz="1300" dirty="0"/>
           </a:p>
         </p:txBody>
       </p:sp>
@@ -11804,7 +11866,7 @@
               <a:buNone/>
             </a:pPr>
             <a:r>
-              <a:rPr lang="en-US" sz="900" dirty="0">
+              <a:rPr lang="en-US" sz="1300" dirty="0">
                 <a:solidFill>
                   <a:srgbClr val="16181D"/>
                 </a:solidFill>
@@ -11814,7 +11876,7 @@
               </a:rPr>
               <a:t>[6] H. Xia, Y. Li, C. T. Leong, et al., "TokenSkip: Controllable chain-of-thought compression in LLMs," 2025, arXiv:2502.12067.</a:t>
             </a:r>
-            <a:endParaRPr lang="en-US" sz="900" dirty="0"/>
+            <a:endParaRPr lang="en-US" sz="1300" dirty="0"/>
           </a:p>
         </p:txBody>
       </p:sp>
@@ -11846,7 +11908,7 @@
               <a:buNone/>
             </a:pPr>
             <a:r>
-              <a:rPr lang="en-US" sz="900" dirty="0">
+              <a:rPr lang="en-US" sz="1300" dirty="0">
                 <a:solidFill>
                   <a:srgbClr val="16181D"/>
                 </a:solidFill>
@@ -11856,7 +11918,7 @@
               </a:rPr>
               <a:t>[7] S. Hao, S. Sukhbaatar, D. Su, et al., "Training large language models to reason in a continuous latent space," 2024, arXiv:2412.06769.</a:t>
             </a:r>
-            <a:endParaRPr lang="en-US" sz="900" dirty="0"/>
+            <a:endParaRPr lang="en-US" sz="1300" dirty="0"/>
           </a:p>
         </p:txBody>
       </p:sp>
@@ -11888,7 +11950,7 @@
               <a:buNone/>
             </a:pPr>
             <a:r>
-              <a:rPr lang="en-US" sz="900" dirty="0">
+              <a:rPr lang="en-US" sz="1300" dirty="0">
                 <a:solidFill>
                   <a:srgbClr val="16181D"/>
                 </a:solidFill>
@@ -11898,7 +11960,7 @@
               </a:rPr>
               <a:t>[8] A. Loukas, "Graph reduction with spectral and cut guarantees," J. Mach. Learn. Res., vol. 20, no. 116, pp. 1-42, 2019.</a:t>
             </a:r>
-            <a:endParaRPr lang="en-US" sz="900" dirty="0"/>
+            <a:endParaRPr lang="en-US" sz="1300" dirty="0"/>
           </a:p>
         </p:txBody>
       </p:sp>
@@ -11930,7 +11992,7 @@
               <a:buNone/>
             </a:pPr>
             <a:r>
-              <a:rPr lang="en-US" sz="900" dirty="0">
+              <a:rPr lang="en-US" sz="1300" dirty="0">
                 <a:solidFill>
                   <a:srgbClr val="16181D"/>
                 </a:solidFill>
@@ -11940,7 +12002,7 @@
               </a:rPr>
               <a:t>[9] W. Kwon, Z. Li, S. Zhuang, et al., "Efficient memory management for large language model serving with PagedAttention," in Proc. ACM SOSP, 2023, arXiv:2309.06180.</a:t>
             </a:r>
-            <a:endParaRPr lang="en-US" sz="900" dirty="0"/>
+            <a:endParaRPr lang="en-US" sz="1300" dirty="0"/>
           </a:p>
         </p:txBody>
       </p:sp>
@@ -12148,7 +12210,7 @@
               <a:buNone/>
             </a:pPr>
             <a:r>
-              <a:rPr lang="en-US" sz="850" dirty="0">
+              <a:rPr lang="en-US" sz="1000" dirty="0">
                 <a:solidFill>
                   <a:srgbClr val="63697A"/>
                 </a:solidFill>
@@ -12158,7 +12220,7 @@
               </a:rPr>
               <a:t>Department of Electrical Engineering</a:t>
             </a:r>
-            <a:endParaRPr lang="en-US" sz="850" dirty="0"/>
+            <a:endParaRPr lang="en-US" sz="1000" dirty="0"/>
           </a:p>
         </p:txBody>
       </p:sp>
@@ -12253,7 +12315,7 @@
               <a:buNone/>
             </a:pPr>
             <a:r>
-              <a:rPr lang="en-US" sz="1050" dirty="0">
+              <a:rPr lang="en-US" sz="1150" dirty="0">
                 <a:solidFill>
                   <a:srgbClr val="63697A"/>
                 </a:solidFill>
@@ -12263,7 +12325,7 @@
               </a:rPr>
               <a:t>github.com/TREX4096/Graph_of_Thought</a:t>
             </a:r>
-            <a:endParaRPr lang="en-US" sz="1050" dirty="0"/>
+            <a:endParaRPr lang="en-US" sz="1150" dirty="0"/>
           </a:p>
         </p:txBody>
       </p:sp>
@@ -12544,7 +12606,7 @@
               <a:buNone/>
             </a:pPr>
             <a:r>
-              <a:rPr lang="en-US" sz="1450" b="1" dirty="0">
+              <a:rPr lang="en-US" sz="1550" b="1" dirty="0">
                 <a:solidFill>
                   <a:srgbClr val="23408E"/>
                 </a:solidFill>
@@ -12554,7 +12616,7 @@
               </a:rPr>
               <a:t>Why does LLM reasoning cost matter ?</a:t>
             </a:r>
-            <a:endParaRPr lang="en-US" sz="1450" dirty="0"/>
+            <a:endParaRPr lang="en-US" sz="1550" dirty="0"/>
           </a:p>
         </p:txBody>
       </p:sp>
@@ -12579,18 +12641,18 @@
           <a:bodyPr wrap="square" lIns="0" tIns="0" rIns="0" bIns="0" rtlCol="0" anchor="ctr"/>
           <a:lstStyle/>
           <a:p>
-            <a:pPr marL="342900" indent="-342900">
+            <a:pPr marL="127000" indent="-127000">
               <a:lnSpc>
-                <a:spcPct val="110000"/>
+                <a:spcPct val="104000"/>
               </a:lnSpc>
               <a:spcAft>
-                <a:spcPts val="700"/>
+                <a:spcPts val="400"/>
               </a:spcAft>
               <a:buSzPct val="100000"/>
               <a:buChar char="•"/>
             </a:pPr>
             <a:r>
-              <a:rPr lang="en-US" sz="1150" dirty="0">
+              <a:rPr lang="en-US" sz="1400" dirty="0">
                 <a:solidFill>
                   <a:srgbClr val="16181D"/>
                 </a:solidFill>
@@ -12600,21 +12662,21 @@
               </a:rPr>
               <a:t>A language model spends identical computation on every token, and cannot allocate more effort to a harder question.</a:t>
             </a:r>
-            <a:endParaRPr lang="en-US" sz="1150" dirty="0"/>
+            <a:endParaRPr lang="en-US" sz="1400" dirty="0"/>
           </a:p>
           <a:p>
-            <a:pPr marL="342900" indent="-342900">
+            <a:pPr marL="127000" indent="-127000">
               <a:lnSpc>
-                <a:spcPct val="110000"/>
+                <a:spcPct val="104000"/>
               </a:lnSpc>
               <a:spcAft>
-                <a:spcPts val="700"/>
+                <a:spcPts val="400"/>
               </a:spcAft>
               <a:buSzPct val="100000"/>
               <a:buChar char="•"/>
             </a:pPr>
             <a:r>
-              <a:rPr lang="en-US" sz="1150" dirty="0">
+              <a:rPr lang="en-US" sz="1400" dirty="0">
                 <a:solidFill>
                   <a:srgbClr val="16181D"/>
                 </a:solidFill>
@@ -12624,21 +12686,21 @@
               </a:rPr>
               <a:t>Structured prompting - Chain, Tree and Graph of Thoughts - buys accuracy by generating many intermediate thoughts.</a:t>
             </a:r>
-            <a:endParaRPr lang="en-US" sz="1150" dirty="0"/>
+            <a:endParaRPr lang="en-US" sz="1400" dirty="0"/>
           </a:p>
           <a:p>
-            <a:pPr marL="342900" indent="-342900">
+            <a:pPr marL="127000" indent="-127000">
               <a:lnSpc>
-                <a:spcPct val="110000"/>
+                <a:spcPct val="104000"/>
               </a:lnSpc>
               <a:spcAft>
-                <a:spcPts val="700"/>
+                <a:spcPts val="400"/>
               </a:spcAft>
               <a:buSzPct val="100000"/>
               <a:buChar char="•"/>
             </a:pPr>
             <a:r>
-              <a:rPr lang="en-US" sz="1150" dirty="0">
+              <a:rPr lang="en-US" sz="1400" dirty="0">
                 <a:solidFill>
                   <a:srgbClr val="16181D"/>
                 </a:solidFill>
@@ -12648,21 +12710,21 @@
               </a:rPr>
               <a:t>Cost scales with the number of thoughts and the length of each. We measure Graph of Thoughts at 15x the tokens of direct prompting.</a:t>
             </a:r>
-            <a:endParaRPr lang="en-US" sz="1150" dirty="0"/>
+            <a:endParaRPr lang="en-US" sz="1400" dirty="0"/>
           </a:p>
           <a:p>
-            <a:pPr marL="342900" indent="-342900">
+            <a:pPr marL="127000" indent="-127000">
               <a:lnSpc>
-                <a:spcPct val="110000"/>
+                <a:spcPct val="104000"/>
               </a:lnSpc>
               <a:spcAft>
-                <a:spcPts val="700"/>
+                <a:spcPts val="400"/>
               </a:spcAft>
               <a:buSzPct val="100000"/>
               <a:buChar char="•"/>
             </a:pPr>
             <a:r>
-              <a:rPr lang="en-US" sz="1150" dirty="0">
+              <a:rPr lang="en-US" sz="1400" dirty="0">
                 <a:solidFill>
                   <a:srgbClr val="16181D"/>
                 </a:solidFill>
@@ -12672,7 +12734,7 @@
               </a:rPr>
               <a:t>Inference cost, not accuracy, is what currently blocks deployment of graph-structured reasoning.</a:t>
             </a:r>
-            <a:endParaRPr lang="en-US" sz="1150" dirty="0"/>
+            <a:endParaRPr lang="en-US" sz="1400" dirty="0"/>
           </a:p>
         </p:txBody>
       </p:sp>
@@ -12701,7 +12763,7 @@
               <a:buNone/>
             </a:pPr>
             <a:r>
-              <a:rPr lang="en-US" sz="1450" b="1" dirty="0">
+              <a:rPr lang="en-US" sz="1550" b="1" dirty="0">
                 <a:solidFill>
                   <a:srgbClr val="23408E"/>
                 </a:solidFill>
@@ -12711,7 +12773,7 @@
               </a:rPr>
               <a:t>Statement</a:t>
             </a:r>
-            <a:endParaRPr lang="en-US" sz="1450" dirty="0"/>
+            <a:endParaRPr lang="en-US" sz="1550" dirty="0"/>
           </a:p>
         </p:txBody>
       </p:sp>
@@ -12738,7 +12800,7 @@
           <a:p>
             <a:pPr indent="0" marL="0">
               <a:lnSpc>
-                <a:spcPct val="112000"/>
+                <a:spcPct val="106000"/>
               </a:lnSpc>
               <a:buNone/>
             </a:pPr>
@@ -12809,7 +12871,7 @@
               <a:buNone/>
             </a:pPr>
             <a:r>
-              <a:rPr lang="en-US" sz="1100" b="1" dirty="0">
+              <a:rPr lang="en-US" sz="1350" b="1" dirty="0">
                 <a:solidFill>
                   <a:srgbClr val="23408E"/>
                 </a:solidFill>
@@ -12819,7 +12881,7 @@
               </a:rPr>
               <a:t>Measured cost per instance</a:t>
             </a:r>
-            <a:endParaRPr lang="en-US" sz="1100" dirty="0"/>
+            <a:endParaRPr lang="en-US" sz="1350" dirty="0"/>
           </a:p>
         </p:txBody>
       </p:sp>
@@ -12833,45 +12895,6 @@
           <a:xfrm>
             <a:off x="8092440" y="1609344"/>
             <a:ext cx="3200400" cy="365760"/>
-          </a:xfrm>
-          <a:prstGeom prst="rect">
-            <a:avLst/>
-          </a:prstGeom>
-          <a:noFill/>
-          <a:ln/>
-        </p:spPr>
-        <p:txBody>
-          <a:bodyPr wrap="square" lIns="0" tIns="0" rIns="0" bIns="0" rtlCol="0" anchor="ctr"/>
-          <a:lstStyle/>
-          <a:p>
-            <a:pPr indent="0" marL="0">
-              <a:buNone/>
-            </a:pPr>
-            <a:r>
-              <a:rPr lang="en-US" sz="850" dirty="0">
-                <a:solidFill>
-                  <a:srgbClr val="63697A"/>
-                </a:solidFill>
-                <a:latin typeface="Montserrat" pitchFamily="34" charset="0"/>
-                <a:ea typeface="Montserrat" pitchFamily="34" charset="-122"/>
-                <a:cs typeface="Montserrat" pitchFamily="34" charset="-120"/>
-              </a:rPr>
-              <a:t>64-element sorting, Qwen2.5-7B, 100 instances</a:t>
-            </a:r>
-            <a:endParaRPr lang="en-US" sz="850" dirty="0"/>
-          </a:p>
-        </p:txBody>
-      </p:sp>
-      <p:sp>
-        <p:nvSpPr>
-          <p:cNvPr id="17" name="Text 15"/>
-          <p:cNvSpPr txBox="1"/>
-          <p:nvPr/>
-        </p:nvSpPr>
-        <p:spPr>
-          <a:xfrm>
-            <a:off x="8092440" y="2121408"/>
-            <a:ext cx="777240" cy="237744"/>
           </a:xfrm>
           <a:prstGeom prst="rect">
             <a:avLst/>
@@ -12889,6 +12912,45 @@
             <a:r>
               <a:rPr lang="en-US" sz="1000" dirty="0">
                 <a:solidFill>
+                  <a:srgbClr val="63697A"/>
+                </a:solidFill>
+                <a:latin typeface="Montserrat" pitchFamily="34" charset="0"/>
+                <a:ea typeface="Montserrat" pitchFamily="34" charset="-122"/>
+                <a:cs typeface="Montserrat" pitchFamily="34" charset="-120"/>
+              </a:rPr>
+              <a:t>64-element sorting, Qwen2.5-7B, 100 instances</a:t>
+            </a:r>
+            <a:endParaRPr lang="en-US" sz="1000" dirty="0"/>
+          </a:p>
+        </p:txBody>
+      </p:sp>
+      <p:sp>
+        <p:nvSpPr>
+          <p:cNvPr id="17" name="Text 15"/>
+          <p:cNvSpPr txBox="1"/>
+          <p:nvPr/>
+        </p:nvSpPr>
+        <p:spPr>
+          <a:xfrm>
+            <a:off x="8092440" y="2121408"/>
+            <a:ext cx="777240" cy="237744"/>
+          </a:xfrm>
+          <a:prstGeom prst="rect">
+            <a:avLst/>
+          </a:prstGeom>
+          <a:noFill/>
+          <a:ln/>
+        </p:spPr>
+        <p:txBody>
+          <a:bodyPr wrap="square" lIns="0" tIns="0" rIns="0" bIns="0" rtlCol="0" anchor="ctr"/>
+          <a:lstStyle/>
+          <a:p>
+            <a:pPr indent="0" marL="0">
+              <a:buNone/>
+            </a:pPr>
+            <a:r>
+              <a:rPr lang="en-US" sz="1250" dirty="0">
+                <a:solidFill>
                   <a:srgbClr val="16181D"/>
                 </a:solidFill>
                 <a:latin typeface="Montserrat" pitchFamily="34" charset="0"/>
@@ -12897,7 +12959,7 @@
               </a:rPr>
               <a:t>IO</a:t>
             </a:r>
-            <a:endParaRPr lang="en-US" sz="1000" dirty="0"/>
+            <a:endParaRPr lang="en-US" sz="1250" dirty="0"/>
           </a:p>
         </p:txBody>
       </p:sp>
@@ -12992,7 +13054,7 @@
               <a:buNone/>
             </a:pPr>
             <a:r>
-              <a:rPr lang="en-US" sz="1000" dirty="0">
+              <a:rPr lang="en-US" sz="1250" dirty="0">
                 <a:solidFill>
                   <a:srgbClr val="16181D"/>
                 </a:solidFill>
@@ -13002,7 +13064,7 @@
               </a:rPr>
               <a:t>CoT</a:t>
             </a:r>
-            <a:endParaRPr lang="en-US" sz="1000" dirty="0"/>
+            <a:endParaRPr lang="en-US" sz="1250" dirty="0"/>
           </a:p>
         </p:txBody>
       </p:sp>
@@ -13097,7 +13159,7 @@
               <a:buNone/>
             </a:pPr>
             <a:r>
-              <a:rPr lang="en-US" sz="1000" dirty="0">
+              <a:rPr lang="en-US" sz="1250" dirty="0">
                 <a:solidFill>
                   <a:srgbClr val="16181D"/>
                 </a:solidFill>
@@ -13107,7 +13169,7 @@
               </a:rPr>
               <a:t>CoT-SC</a:t>
             </a:r>
-            <a:endParaRPr lang="en-US" sz="1000" dirty="0"/>
+            <a:endParaRPr lang="en-US" sz="1250" dirty="0"/>
           </a:p>
         </p:txBody>
       </p:sp>
@@ -13202,7 +13264,7 @@
               <a:buNone/>
             </a:pPr>
             <a:r>
-              <a:rPr lang="en-US" sz="1000" dirty="0">
+              <a:rPr lang="en-US" sz="1250" dirty="0">
                 <a:solidFill>
                   <a:srgbClr val="16181D"/>
                 </a:solidFill>
@@ -13212,7 +13274,7 @@
               </a:rPr>
               <a:t>ToT</a:t>
             </a:r>
-            <a:endParaRPr lang="en-US" sz="1000" dirty="0"/>
+            <a:endParaRPr lang="en-US" sz="1250" dirty="0"/>
           </a:p>
         </p:txBody>
       </p:sp>
@@ -13307,7 +13369,7 @@
               <a:buNone/>
             </a:pPr>
             <a:r>
-              <a:rPr lang="en-US" sz="1000" dirty="0">
+              <a:rPr lang="en-US" sz="1250" dirty="0">
                 <a:solidFill>
                   <a:srgbClr val="16181D"/>
                 </a:solidFill>
@@ -13317,7 +13379,7 @@
               </a:rPr>
               <a:t>GoT</a:t>
             </a:r>
-            <a:endParaRPr lang="en-US" sz="1000" dirty="0"/>
+            <a:endParaRPr lang="en-US" sz="1250" dirty="0"/>
           </a:p>
         </p:txBody>
       </p:sp>
@@ -13412,7 +13474,7 @@
               <a:buNone/>
             </a:pPr>
             <a:r>
-              <a:rPr lang="en-US" sz="850" i="1" dirty="0">
+              <a:rPr lang="en-US" sz="1000" i="1" dirty="0">
                 <a:solidFill>
                   <a:srgbClr val="63697A"/>
                 </a:solidFill>
@@ -13422,7 +13484,7 @@
               </a:rPr>
               <a:t>mean tokens consumed</a:t>
             </a:r>
-            <a:endParaRPr lang="en-US" sz="850" dirty="0"/>
+            <a:endParaRPr lang="en-US" sz="1000" dirty="0"/>
           </a:p>
         </p:txBody>
       </p:sp>
@@ -13703,7 +13765,7 @@
               <a:buNone/>
             </a:pPr>
             <a:r>
-              <a:rPr lang="en-US" sz="1450" b="1" dirty="0">
+              <a:rPr lang="en-US" sz="1550" b="1" dirty="0">
                 <a:solidFill>
                   <a:srgbClr val="23408E"/>
                 </a:solidFill>
@@ -13713,7 +13775,7 @@
               </a:rPr>
               <a:t>Paper 1 : Chain-of-Thought Prompting Elicits Reasoning in Large Language Models</a:t>
             </a:r>
-            <a:endParaRPr lang="en-US" sz="1450" dirty="0"/>
+            <a:endParaRPr lang="en-US" sz="1550" dirty="0"/>
           </a:p>
         </p:txBody>
       </p:sp>
@@ -13742,7 +13804,7 @@
               <a:buNone/>
             </a:pPr>
             <a:r>
-              <a:rPr lang="en-US" sz="1100" i="1" dirty="0">
+              <a:rPr lang="en-US" sz="1250" i="1" dirty="0">
                 <a:solidFill>
                   <a:srgbClr val="63697A"/>
                 </a:solidFill>
@@ -13752,7 +13814,7 @@
               </a:rPr>
               <a:t>( Chain structure - intermediate steps written into the prompt )</a:t>
             </a:r>
-            <a:endParaRPr lang="en-US" sz="1100" dirty="0"/>
+            <a:endParaRPr lang="en-US" sz="1250" dirty="0"/>
           </a:p>
         </p:txBody>
       </p:sp>
@@ -13777,18 +13839,18 @@
           <a:bodyPr wrap="square" lIns="0" tIns="0" rIns="0" bIns="0" rtlCol="0" anchor="ctr"/>
           <a:lstStyle/>
           <a:p>
-            <a:pPr marL="342900" indent="-342900">
+            <a:pPr marL="127000" indent="-127000">
               <a:lnSpc>
-                <a:spcPct val="110000"/>
+                <a:spcPct val="104000"/>
               </a:lnSpc>
               <a:spcAft>
-                <a:spcPts val="700"/>
+                <a:spcPts val="400"/>
               </a:spcAft>
               <a:buSzPct val="100000"/>
               <a:buChar char="•"/>
             </a:pPr>
             <a:r>
-              <a:rPr lang="en-US" sz="1150" dirty="0">
+              <a:rPr lang="en-US" sz="1400" dirty="0">
                 <a:solidFill>
                   <a:srgbClr val="16181D"/>
                 </a:solidFill>
@@ -13798,21 +13860,21 @@
               </a:rPr>
               <a:t>Intermediate reasoning steps are emitted before the answer, with no change to model weights.</a:t>
             </a:r>
-            <a:endParaRPr lang="en-US" sz="1150" dirty="0"/>
+            <a:endParaRPr lang="en-US" sz="1400" dirty="0"/>
           </a:p>
           <a:p>
-            <a:pPr marL="342900" indent="-342900">
+            <a:pPr marL="127000" indent="-127000">
               <a:lnSpc>
-                <a:spcPct val="110000"/>
+                <a:spcPct val="104000"/>
               </a:lnSpc>
               <a:spcAft>
-                <a:spcPts val="700"/>
+                <a:spcPts val="400"/>
               </a:spcAft>
               <a:buSzPct val="100000"/>
               <a:buChar char="•"/>
             </a:pPr>
             <a:r>
-              <a:rPr lang="en-US" sz="1150" dirty="0">
+              <a:rPr lang="en-US" sz="1400" dirty="0">
                 <a:solidFill>
                   <a:srgbClr val="16181D"/>
                 </a:solidFill>
@@ -13822,21 +13884,21 @@
               </a:rPr>
               <a:t>More tokens means more forward passes - the written chain IS the additional computation.</a:t>
             </a:r>
-            <a:endParaRPr lang="en-US" sz="1150" dirty="0"/>
+            <a:endParaRPr lang="en-US" sz="1400" dirty="0"/>
           </a:p>
           <a:p>
-            <a:pPr marL="342900" indent="-342900">
+            <a:pPr marL="127000" indent="-127000">
               <a:lnSpc>
-                <a:spcPct val="110000"/>
+                <a:spcPct val="104000"/>
               </a:lnSpc>
               <a:spcAft>
-                <a:spcPts val="700"/>
+                <a:spcPts val="400"/>
               </a:spcAft>
               <a:buSzPct val="100000"/>
               <a:buChar char="•"/>
             </a:pPr>
             <a:r>
-              <a:rPr lang="en-US" sz="1150" dirty="0">
+              <a:rPr lang="en-US" sz="1400" dirty="0">
                 <a:solidFill>
                   <a:srgbClr val="16181D"/>
                 </a:solidFill>
@@ -13846,21 +13908,21 @@
               </a:rPr>
               <a:t>GSM8K solve rate rises from 18% to 57% on PaLM-540B under chain-of-thought prompting.</a:t>
             </a:r>
-            <a:endParaRPr lang="en-US" sz="1150" dirty="0"/>
+            <a:endParaRPr lang="en-US" sz="1400" dirty="0"/>
           </a:p>
           <a:p>
-            <a:pPr marL="342900" indent="-342900">
+            <a:pPr marL="127000" indent="-127000">
               <a:lnSpc>
-                <a:spcPct val="110000"/>
+                <a:spcPct val="104000"/>
               </a:lnSpc>
               <a:spcAft>
-                <a:spcPts val="700"/>
+                <a:spcPts val="400"/>
               </a:spcAft>
               <a:buSzPct val="100000"/>
               <a:buChar char="•"/>
             </a:pPr>
             <a:r>
-              <a:rPr lang="en-US" sz="1150" dirty="0">
+              <a:rPr lang="en-US" sz="1400" dirty="0">
                 <a:solidFill>
                   <a:srgbClr val="16181D"/>
                 </a:solidFill>
@@ -13870,7 +13932,7 @@
               </a:rPr>
               <a:t>The ability is emergent: below roughly 10B parameters chains are fluent but logically invalid, and accuracy can fall below direct prompting.</a:t>
             </a:r>
-            <a:endParaRPr lang="en-US" sz="1150" dirty="0"/>
+            <a:endParaRPr lang="en-US" sz="1400" dirty="0"/>
           </a:p>
         </p:txBody>
       </p:sp>
@@ -13926,7 +13988,7 @@
               <a:buNone/>
             </a:pPr>
             <a:r>
-              <a:rPr lang="en-US" sz="1100" b="1" dirty="0">
+              <a:rPr lang="en-US" sz="1350" b="1" dirty="0">
                 <a:solidFill>
                   <a:srgbClr val="23408E"/>
                 </a:solidFill>
@@ -13936,7 +13998,7 @@
               </a:rPr>
               <a:t>Structure</a:t>
             </a:r>
-            <a:endParaRPr lang="en-US" sz="1100" dirty="0"/>
+            <a:endParaRPr lang="en-US" sz="1350" dirty="0"/>
           </a:p>
         </p:txBody>
       </p:sp>
@@ -14416,7 +14478,7 @@
               <a:buNone/>
             </a:pPr>
             <a:r>
-              <a:rPr lang="en-US" sz="900" i="1" dirty="0">
+              <a:rPr lang="en-US" sz="1050" i="1" dirty="0">
                 <a:solidFill>
                   <a:srgbClr val="63697A"/>
                 </a:solidFill>
@@ -14426,7 +14488,7 @@
               </a:rPr>
               <a:t>Wei et al., NeurIPS 2022, arXiv:2201.11903</a:t>
             </a:r>
-            <a:endParaRPr lang="en-US" sz="900" dirty="0"/>
+            <a:endParaRPr lang="en-US" sz="1050" dirty="0"/>
           </a:p>
         </p:txBody>
       </p:sp>
@@ -14707,7 +14769,7 @@
               <a:buNone/>
             </a:pPr>
             <a:r>
-              <a:rPr lang="en-US" sz="1450" b="1" dirty="0">
+              <a:rPr lang="en-US" sz="1550" b="1" dirty="0">
                 <a:solidFill>
                   <a:srgbClr val="23408E"/>
                 </a:solidFill>
@@ -14717,7 +14779,7 @@
               </a:rPr>
               <a:t>Paper 2 : Tree of Thoughts - Deliberate Problem Solving with Large Language Models</a:t>
             </a:r>
-            <a:endParaRPr lang="en-US" sz="1450" dirty="0"/>
+            <a:endParaRPr lang="en-US" sz="1550" dirty="0"/>
           </a:p>
         </p:txBody>
       </p:sp>
@@ -14746,7 +14808,7 @@
               <a:buNone/>
             </a:pPr>
             <a:r>
-              <a:rPr lang="en-US" sz="1100" i="1" dirty="0">
+              <a:rPr lang="en-US" sz="1250" i="1" dirty="0">
                 <a:solidFill>
                   <a:srgbClr val="63697A"/>
                 </a:solidFill>
@@ -14756,7 +14818,7 @@
               </a:rPr>
               <a:t>( Tree structure - branching, evaluation and backtracking )</a:t>
             </a:r>
-            <a:endParaRPr lang="en-US" sz="1100" dirty="0"/>
+            <a:endParaRPr lang="en-US" sz="1250" dirty="0"/>
           </a:p>
         </p:txBody>
       </p:sp>
@@ -14781,18 +14843,18 @@
           <a:bodyPr wrap="square" lIns="0" tIns="0" rIns="0" bIns="0" rtlCol="0" anchor="ctr"/>
           <a:lstStyle/>
           <a:p>
-            <a:pPr marL="342900" indent="-342900">
+            <a:pPr marL="127000" indent="-127000">
               <a:lnSpc>
-                <a:spcPct val="110000"/>
+                <a:spcPct val="104000"/>
               </a:lnSpc>
               <a:spcAft>
-                <a:spcPts val="700"/>
+                <a:spcPts val="400"/>
               </a:spcAft>
               <a:buSzPct val="100000"/>
               <a:buChar char="•"/>
             </a:pPr>
             <a:r>
-              <a:rPr lang="en-US" sz="1150" dirty="0">
+              <a:rPr lang="en-US" sz="1400" dirty="0">
                 <a:solidFill>
                   <a:srgbClr val="16181D"/>
                 </a:solidFill>
@@ -14802,21 +14864,21 @@
               </a:rPr>
               <a:t>Three components: a thought generator producing k children, a state evaluator scoring them, and a search algorithm over the tree.</a:t>
             </a:r>
-            <a:endParaRPr lang="en-US" sz="1150" dirty="0"/>
+            <a:endParaRPr lang="en-US" sz="1400" dirty="0"/>
           </a:p>
           <a:p>
-            <a:pPr marL="342900" indent="-342900">
+            <a:pPr marL="127000" indent="-127000">
               <a:lnSpc>
-                <a:spcPct val="110000"/>
+                <a:spcPct val="104000"/>
               </a:lnSpc>
               <a:spcAft>
-                <a:spcPts val="700"/>
+                <a:spcPts val="400"/>
               </a:spcAft>
               <a:buSzPct val="100000"/>
               <a:buChar char="•"/>
             </a:pPr>
             <a:r>
-              <a:rPr lang="en-US" sz="1150" dirty="0">
+              <a:rPr lang="en-US" sz="1400" dirty="0">
                 <a:solidFill>
                   <a:srgbClr val="16181D"/>
                 </a:solidFill>
@@ -14826,21 +14888,21 @@
               </a:rPr>
               <a:t>Adds local exploration and backtracking, which Self-Consistency with CoT cannot do - its k chains never exchange information.</a:t>
             </a:r>
-            <a:endParaRPr lang="en-US" sz="1150" dirty="0"/>
+            <a:endParaRPr lang="en-US" sz="1400" dirty="0"/>
           </a:p>
           <a:p>
-            <a:pPr marL="342900" indent="-342900">
+            <a:pPr marL="127000" indent="-127000">
               <a:lnSpc>
-                <a:spcPct val="110000"/>
+                <a:spcPct val="104000"/>
               </a:lnSpc>
               <a:spcAft>
-                <a:spcPts val="700"/>
+                <a:spcPts val="400"/>
               </a:spcAft>
               <a:buSzPct val="100000"/>
               <a:buChar char="•"/>
             </a:pPr>
             <a:r>
-              <a:rPr lang="en-US" sz="1150" dirty="0">
+              <a:rPr lang="en-US" sz="1400" dirty="0">
                 <a:solidFill>
                   <a:srgbClr val="16181D"/>
                 </a:solidFill>
@@ -14850,21 +14912,21 @@
               </a:rPr>
               <a:t>Every vertex has exactly one parent, so information on a discarded branch is lost permanently.</a:t>
             </a:r>
-            <a:endParaRPr lang="en-US" sz="1150" dirty="0"/>
+            <a:endParaRPr lang="en-US" sz="1400" dirty="0"/>
           </a:p>
           <a:p>
-            <a:pPr marL="342900" indent="-342900">
+            <a:pPr marL="127000" indent="-127000">
               <a:lnSpc>
-                <a:spcPct val="110000"/>
+                <a:spcPct val="104000"/>
               </a:lnSpc>
               <a:spcAft>
-                <a:spcPts val="700"/>
+                <a:spcPts val="400"/>
               </a:spcAft>
               <a:buSzPct val="100000"/>
               <a:buChar char="•"/>
             </a:pPr>
             <a:r>
-              <a:rPr lang="en-US" sz="1150" dirty="0">
+              <a:rPr lang="en-US" sz="1400" dirty="0">
                 <a:solidFill>
                   <a:srgbClr val="16181D"/>
                 </a:solidFill>
@@ -14874,7 +14936,7 @@
               </a:rPr>
               <a:t>In our replication ToT is the strongest baseline, once its evaluator can reject a refinement that worsens the answer.</a:t>
             </a:r>
-            <a:endParaRPr lang="en-US" sz="1150" dirty="0"/>
+            <a:endParaRPr lang="en-US" sz="1400" dirty="0"/>
           </a:p>
         </p:txBody>
       </p:sp>
@@ -14930,7 +14992,7 @@
               <a:buNone/>
             </a:pPr>
             <a:r>
-              <a:rPr lang="en-US" sz="1100" b="1" dirty="0">
+              <a:rPr lang="en-US" sz="1350" b="1" dirty="0">
                 <a:solidFill>
                   <a:srgbClr val="23408E"/>
                 </a:solidFill>
@@ -14940,7 +15002,7 @@
               </a:rPr>
               <a:t>Structure</a:t>
             </a:r>
-            <a:endParaRPr lang="en-US" sz="1100" dirty="0"/>
+            <a:endParaRPr lang="en-US" sz="1350" dirty="0"/>
           </a:p>
         </p:txBody>
       </p:sp>
@@ -15465,7 +15527,7 @@
               <a:buNone/>
             </a:pPr>
             <a:r>
-              <a:rPr lang="en-US" sz="900" i="1" dirty="0">
+              <a:rPr lang="en-US" sz="1050" i="1" dirty="0">
                 <a:solidFill>
                   <a:srgbClr val="63697A"/>
                 </a:solidFill>
@@ -15475,7 +15537,7 @@
               </a:rPr>
               <a:t>Yao et al., NeurIPS 2023, arXiv:2305.10601</a:t>
             </a:r>
-            <a:endParaRPr lang="en-US" sz="900" dirty="0"/>
+            <a:endParaRPr lang="en-US" sz="1050" dirty="0"/>
           </a:p>
         </p:txBody>
       </p:sp>
@@ -15756,7 +15818,7 @@
               <a:buNone/>
             </a:pPr>
             <a:r>
-              <a:rPr lang="en-US" sz="1450" b="1" dirty="0">
+              <a:rPr lang="en-US" sz="1550" b="1" dirty="0">
                 <a:solidFill>
                   <a:srgbClr val="23408E"/>
                 </a:solidFill>
@@ -15766,7 +15828,7 @@
               </a:rPr>
               <a:t>Paper 3 : Graph of Thoughts - Solving Elaborate Problems with Large Language Models</a:t>
             </a:r>
-            <a:endParaRPr lang="en-US" sz="1450" dirty="0"/>
+            <a:endParaRPr lang="en-US" sz="1550" dirty="0"/>
           </a:p>
         </p:txBody>
       </p:sp>
@@ -15830,18 +15892,18 @@
           <a:bodyPr wrap="square" lIns="0" tIns="0" rIns="0" bIns="0" rtlCol="0" anchor="ctr"/>
           <a:lstStyle/>
           <a:p>
-            <a:pPr marL="342900" indent="-342900">
+            <a:pPr marL="127000" indent="-127000">
               <a:lnSpc>
-                <a:spcPct val="110000"/>
+                <a:spcPct val="104000"/>
               </a:lnSpc>
               <a:spcAft>
-                <a:spcPts val="700"/>
+                <a:spcPts val="400"/>
               </a:spcAft>
               <a:buSzPct val="100000"/>
               <a:buChar char="•"/>
             </a:pPr>
             <a:r>
-              <a:rPr lang="en-US" sz="1150" dirty="0">
+              <a:rPr lang="en-US" sz="1400" dirty="0">
                 <a:solidFill>
                   <a:srgbClr val="16181D"/>
                 </a:solidFill>
@@ -15851,21 +15913,21 @@
               </a:rPr>
               <a:t>Reasoning is a directed graph: vertices are thoughts, and an edge (a,b) means a's text was the direct input that produced b.</a:t>
             </a:r>
-            <a:endParaRPr lang="en-US" sz="1150" dirty="0"/>
+            <a:endParaRPr lang="en-US" sz="1400" dirty="0"/>
           </a:p>
           <a:p>
-            <a:pPr marL="342900" indent="-342900">
+            <a:pPr marL="127000" indent="-127000">
               <a:lnSpc>
-                <a:spcPct val="110000"/>
+                <a:spcPct val="104000"/>
               </a:lnSpc>
               <a:spcAft>
-                <a:spcPts val="700"/>
+                <a:spcPts val="400"/>
               </a:spcAft>
               <a:buSzPct val="100000"/>
               <a:buChar char="•"/>
             </a:pPr>
             <a:r>
-              <a:rPr lang="en-US" sz="1150" dirty="0">
+              <a:rPr lang="en-US" sz="1400" dirty="0">
                 <a:solidFill>
                   <a:srgbClr val="16181D"/>
                 </a:solidFill>
@@ -15875,21 +15937,21 @@
               </a:rPr>
               <a:t>Aggregation merges k thoughts into one, creating a vertex of in-degree k &gt; 1 - which a tree cannot contain, by definition.</a:t>
             </a:r>
-            <a:endParaRPr lang="en-US" sz="1150" dirty="0"/>
+            <a:endParaRPr lang="en-US" sz="1400" dirty="0"/>
           </a:p>
           <a:p>
-            <a:pPr marL="342900" indent="-342900">
+            <a:pPr marL="127000" indent="-127000">
               <a:lnSpc>
-                <a:spcPct val="110000"/>
+                <a:spcPct val="104000"/>
               </a:lnSpc>
               <a:spcAft>
-                <a:spcPts val="700"/>
+                <a:spcPts val="400"/>
               </a:spcAft>
               <a:buSzPct val="100000"/>
               <a:buChar char="•"/>
             </a:pPr>
             <a:r>
-              <a:rPr lang="en-US" sz="1150" dirty="0">
+              <a:rPr lang="en-US" sz="1400" dirty="0">
                 <a:solidFill>
                   <a:srgbClr val="16181D"/>
                 </a:solidFill>
@@ -15899,21 +15961,21 @@
               </a:rPr>
               <a:t>Reported gains of 62% in sorting quality over ToT with a 31% cost reduction, on ChatGPT-3.5.</a:t>
             </a:r>
-            <a:endParaRPr lang="en-US" sz="1150" dirty="0"/>
+            <a:endParaRPr lang="en-US" sz="1400" dirty="0"/>
           </a:p>
           <a:p>
-            <a:pPr marL="342900" indent="-342900">
+            <a:pPr marL="127000" indent="-127000">
               <a:lnSpc>
-                <a:spcPct val="110000"/>
+                <a:spcPct val="104000"/>
               </a:lnSpc>
               <a:spcAft>
-                <a:spcPts val="700"/>
+                <a:spcPts val="400"/>
               </a:spcAft>
               <a:buSzPct val="100000"/>
               <a:buChar char="•"/>
             </a:pPr>
             <a:r>
-              <a:rPr lang="en-US" sz="1150" dirty="0">
+              <a:rPr lang="en-US" sz="1400" dirty="0">
                 <a:solidFill>
                   <a:srgbClr val="16181D"/>
                 </a:solidFill>
@@ -15923,7 +15985,7 @@
               </a:rPr>
               <a:t>Latency log-k N at volume N: the only scheme where every computed thought retains a causal path to the answer.</a:t>
             </a:r>
-            <a:endParaRPr lang="en-US" sz="1150" dirty="0"/>
+            <a:endParaRPr lang="en-US" sz="1400" dirty="0"/>
           </a:p>
         </p:txBody>
       </p:sp>
@@ -15979,7 +16041,7 @@
               <a:buNone/>
             </a:pPr>
             <a:r>
-              <a:rPr lang="en-US" sz="1050" b="1" dirty="0">
+              <a:rPr lang="en-US" sz="1200" b="1" dirty="0">
                 <a:solidFill>
                   <a:srgbClr val="D98A1F"/>
                 </a:solidFill>
@@ -15989,7 +16051,7 @@
               </a:rPr>
               <a:t>Structure - merge sort executed by an LLM</a:t>
             </a:r>
-            <a:endParaRPr lang="en-US" sz="1050" dirty="0"/>
+            <a:endParaRPr lang="en-US" sz="1200" dirty="0"/>
           </a:p>
         </p:txBody>
       </p:sp>
@@ -16448,7 +16510,7 @@
               <a:buNone/>
             </a:pPr>
             <a:r>
-              <a:rPr lang="en-US" sz="950" dirty="0">
+              <a:rPr lang="en-US" sz="1300" dirty="0">
                 <a:solidFill>
                   <a:srgbClr val="16181D"/>
                 </a:solidFill>
@@ -16458,7 +16520,7 @@
               </a:rPr>
               <a:t>split  -&gt;  sort chunks  -&gt;  merge  -&gt;  merge</a:t>
             </a:r>
-            <a:endParaRPr lang="en-US" sz="950" dirty="0"/>
+            <a:endParaRPr lang="en-US" sz="1300" dirty="0"/>
           </a:p>
         </p:txBody>
       </p:sp>
@@ -16487,7 +16549,7 @@
               <a:buNone/>
             </a:pPr>
             <a:r>
-              <a:rPr lang="en-US" sz="900" i="1" dirty="0">
+              <a:rPr lang="en-US" sz="1050" i="1" dirty="0">
                 <a:solidFill>
                   <a:srgbClr val="63697A"/>
                 </a:solidFill>
@@ -16497,7 +16559,7 @@
               </a:rPr>
               <a:t>Besta et al., AAAI 2024, arXiv:2308.09687</a:t>
             </a:r>
-            <a:endParaRPr lang="en-US" sz="900" dirty="0"/>
+            <a:endParaRPr lang="en-US" sz="1050" dirty="0"/>
           </a:p>
         </p:txBody>
       </p:sp>
@@ -16778,7 +16840,7 @@
               <a:buNone/>
             </a:pPr>
             <a:r>
-              <a:rPr lang="en-US" sz="1450" b="1" dirty="0">
+              <a:rPr lang="en-US" sz="1550" b="1" dirty="0">
                 <a:solidFill>
                   <a:srgbClr val="23408E"/>
                 </a:solidFill>
@@ -16788,7 +16850,7 @@
               </a:rPr>
               <a:t>Paper 4 : Compression of Chain-of-Thought Reasoning</a:t>
             </a:r>
-            <a:endParaRPr lang="en-US" sz="1450" dirty="0"/>
+            <a:endParaRPr lang="en-US" sz="1550" dirty="0"/>
           </a:p>
         </p:txBody>
       </p:sp>
@@ -16817,7 +16879,7 @@
               <a:buNone/>
             </a:pPr>
             <a:r>
-              <a:rPr lang="en-US" sz="1100" i="1" dirty="0">
+              <a:rPr lang="en-US" sz="1250" i="1" dirty="0">
                 <a:solidFill>
                   <a:srgbClr val="63697A"/>
                 </a:solidFill>
@@ -16827,7 +16889,7 @@
               </a:rPr>
               <a:t>( The literature we borrow from - all of it operates on a single chain )</a:t>
             </a:r>
-            <a:endParaRPr lang="en-US" sz="1100" dirty="0"/>
+            <a:endParaRPr lang="en-US" sz="1250" dirty="0"/>
           </a:p>
         </p:txBody>
       </p:sp>
@@ -16868,7 +16930,7 @@
                         <a:buNone/>
                       </a:pPr>
                       <a:r>
-                        <a:rPr lang="en-US" sz="950" b="1" dirty="0">
+                        <a:rPr lang="en-US" sz="1150" b="1" dirty="0">
                           <a:solidFill>
                             <a:srgbClr val="FFFFFF"/>
                           </a:solidFill>
@@ -16878,7 +16940,7 @@
                         </a:rPr>
                         <a:t>Method</a:t>
                       </a:r>
-                      <a:endParaRPr lang="en-US" sz="950" dirty="0">
+                      <a:endParaRPr lang="en-US" sz="1150" dirty="0">
                         <a:latin typeface="Montserrat" charset="0"/>
                         <a:ea typeface="Montserrat" charset="0"/>
                         <a:cs typeface="Montserrat" charset="0"/>
@@ -16936,7 +16998,7 @@
                         <a:buNone/>
                       </a:pPr>
                       <a:r>
-                        <a:rPr lang="en-US" sz="950" b="1" dirty="0">
+                        <a:rPr lang="en-US" sz="1150" b="1" dirty="0">
                           <a:solidFill>
                             <a:srgbClr val="FFFFFF"/>
                           </a:solidFill>
@@ -16946,7 +17008,7 @@
                         </a:rPr>
                         <a:t>Mechanism</a:t>
                       </a:r>
-                      <a:endParaRPr lang="en-US" sz="950" dirty="0">
+                      <a:endParaRPr lang="en-US" sz="1150" dirty="0">
                         <a:latin typeface="Montserrat" charset="0"/>
                         <a:ea typeface="Montserrat" charset="0"/>
                         <a:cs typeface="Montserrat" charset="0"/>
@@ -17004,7 +17066,7 @@
                         <a:buNone/>
                       </a:pPr>
                       <a:r>
-                        <a:rPr lang="en-US" sz="950" b="1" dirty="0">
+                        <a:rPr lang="en-US" sz="1150" b="1" dirty="0">
                           <a:solidFill>
                             <a:srgbClr val="FFFFFF"/>
                           </a:solidFill>
@@ -17014,7 +17076,7 @@
                         </a:rPr>
                         <a:t>Reported effect</a:t>
                       </a:r>
-                      <a:endParaRPr lang="en-US" sz="950" dirty="0">
+                      <a:endParaRPr lang="en-US" sz="1150" dirty="0">
                         <a:latin typeface="Montserrat" charset="0"/>
                         <a:ea typeface="Montserrat" charset="0"/>
                         <a:cs typeface="Montserrat" charset="0"/>
@@ -17074,7 +17136,7 @@
                         <a:buNone/>
                       </a:pPr>
                       <a:r>
-                        <a:rPr lang="en-US" sz="950" b="1" dirty="0">
+                        <a:rPr lang="en-US" sz="1150" b="1" dirty="0">
                           <a:solidFill>
                             <a:srgbClr val="16181D"/>
                           </a:solidFill>
@@ -17084,7 +17146,7 @@
                         </a:rPr>
                         <a:t>Chain of Draft</a:t>
                       </a:r>
-                      <a:endParaRPr lang="en-US" sz="950" dirty="0">
+                      <a:endParaRPr lang="en-US" sz="1150" dirty="0">
                         <a:latin typeface="Montserrat" charset="0"/>
                         <a:ea typeface="Montserrat" charset="0"/>
                         <a:cs typeface="Montserrat" charset="0"/>
@@ -17142,7 +17204,7 @@
                         <a:buNone/>
                       </a:pPr>
                       <a:r>
-                        <a:rPr lang="en-US" sz="950" dirty="0">
+                        <a:rPr lang="en-US" sz="1150" dirty="0">
                           <a:solidFill>
                             <a:srgbClr val="16181D"/>
                           </a:solidFill>
@@ -17152,7 +17214,7 @@
                         </a:rPr>
                         <a:t>Cap each reasoning step to a few words</a:t>
                       </a:r>
-                      <a:endParaRPr lang="en-US" sz="950" dirty="0">
+                      <a:endParaRPr lang="en-US" sz="1150" dirty="0">
                         <a:latin typeface="Montserrat" charset="0"/>
                         <a:ea typeface="Montserrat" charset="0"/>
                         <a:cs typeface="Montserrat" charset="0"/>
@@ -17210,7 +17272,7 @@
                         <a:buNone/>
                       </a:pPr>
                       <a:r>
-                        <a:rPr lang="en-US" sz="950" dirty="0">
+                        <a:rPr lang="en-US" sz="1150" dirty="0">
                           <a:solidFill>
                             <a:srgbClr val="16181D"/>
                           </a:solidFill>
@@ -17220,7 +17282,7 @@
                         </a:rPr>
                         <a:t>~7.6% of CoT tokens, accuracy retained</a:t>
                       </a:r>
-                      <a:endParaRPr lang="en-US" sz="950" dirty="0">
+                      <a:endParaRPr lang="en-US" sz="1150" dirty="0">
                         <a:latin typeface="Montserrat" charset="0"/>
                         <a:ea typeface="Montserrat" charset="0"/>
                         <a:cs typeface="Montserrat" charset="0"/>
@@ -17280,7 +17342,7 @@
                         <a:buNone/>
                       </a:pPr>
                       <a:r>
-                        <a:rPr lang="en-US" sz="950" b="1" dirty="0">
+                        <a:rPr lang="en-US" sz="1150" b="1" dirty="0">
                           <a:solidFill>
                             <a:srgbClr val="16181D"/>
                           </a:solidFill>
@@ -17290,7 +17352,7 @@
                         </a:rPr>
                         <a:t>TokenSkip</a:t>
                       </a:r>
-                      <a:endParaRPr lang="en-US" sz="950" dirty="0">
+                      <a:endParaRPr lang="en-US" sz="1150" dirty="0">
                         <a:latin typeface="Montserrat" charset="0"/>
                         <a:ea typeface="Montserrat" charset="0"/>
                         <a:cs typeface="Montserrat" charset="0"/>
@@ -17348,7 +17410,7 @@
                         <a:buNone/>
                       </a:pPr>
                       <a:r>
-                        <a:rPr lang="en-US" sz="950" dirty="0">
+                        <a:rPr lang="en-US" sz="1150" dirty="0">
                           <a:solidFill>
                             <a:srgbClr val="16181D"/>
                           </a:solidFill>
@@ -17358,7 +17420,7 @@
                         </a:rPr>
                         <a:t>Prune low-utility tokens from the chain</a:t>
                       </a:r>
-                      <a:endParaRPr lang="en-US" sz="950" dirty="0">
+                      <a:endParaRPr lang="en-US" sz="1150" dirty="0">
                         <a:latin typeface="Montserrat" charset="0"/>
                         <a:ea typeface="Montserrat" charset="0"/>
                         <a:cs typeface="Montserrat" charset="0"/>
@@ -17416,7 +17478,7 @@
                         <a:buNone/>
                       </a:pPr>
                       <a:r>
-                        <a:rPr lang="en-US" sz="950" dirty="0">
+                        <a:rPr lang="en-US" sz="1150" dirty="0">
                           <a:solidFill>
                             <a:srgbClr val="16181D"/>
                           </a:solidFill>
@@ -17426,7 +17488,7 @@
                         </a:rPr>
                         <a:t>Controllable compression ratio</a:t>
                       </a:r>
-                      <a:endParaRPr lang="en-US" sz="950" dirty="0">
+                      <a:endParaRPr lang="en-US" sz="1150" dirty="0">
                         <a:latin typeface="Montserrat" charset="0"/>
                         <a:ea typeface="Montserrat" charset="0"/>
                         <a:cs typeface="Montserrat" charset="0"/>
@@ -17486,7 +17548,7 @@
                         <a:buNone/>
                       </a:pPr>
                       <a:r>
-                        <a:rPr lang="en-US" sz="950" b="1" dirty="0">
+                        <a:rPr lang="en-US" sz="1150" b="1" dirty="0">
                           <a:solidFill>
                             <a:srgbClr val="16181D"/>
                           </a:solidFill>
@@ -17496,7 +17558,7 @@
                         </a:rPr>
                         <a:t>Coconut</a:t>
                       </a:r>
-                      <a:endParaRPr lang="en-US" sz="950" dirty="0">
+                      <a:endParaRPr lang="en-US" sz="1150" dirty="0">
                         <a:latin typeface="Montserrat" charset="0"/>
                         <a:ea typeface="Montserrat" charset="0"/>
                         <a:cs typeface="Montserrat" charset="0"/>
@@ -17554,7 +17616,7 @@
                         <a:buNone/>
                       </a:pPr>
                       <a:r>
-                        <a:rPr lang="en-US" sz="950" dirty="0">
+                        <a:rPr lang="en-US" sz="1150" dirty="0">
                           <a:solidFill>
                             <a:srgbClr val="16181D"/>
                           </a:solidFill>
@@ -17564,7 +17626,7 @@
                         </a:rPr>
                         <a:t>Feed the hidden state back instead of decoding</a:t>
                       </a:r>
-                      <a:endParaRPr lang="en-US" sz="950" dirty="0">
+                      <a:endParaRPr lang="en-US" sz="1150" dirty="0">
                         <a:latin typeface="Montserrat" charset="0"/>
                         <a:ea typeface="Montserrat" charset="0"/>
                         <a:cs typeface="Montserrat" charset="0"/>
@@ -17622,7 +17684,7 @@
                         <a:buNone/>
                       </a:pPr>
                       <a:r>
-                        <a:rPr lang="en-US" sz="950" dirty="0">
+                        <a:rPr lang="en-US" sz="1150" dirty="0">
                           <a:solidFill>
                             <a:srgbClr val="16181D"/>
                           </a:solidFill>
@@ -17632,7 +17694,7 @@
                         </a:rPr>
                         <a:t>Reasoning without emitting text tokens</a:t>
                       </a:r>
-                      <a:endParaRPr lang="en-US" sz="950" dirty="0">
+                      <a:endParaRPr lang="en-US" sz="1150" dirty="0">
                         <a:latin typeface="Montserrat" charset="0"/>
                         <a:ea typeface="Montserrat" charset="0"/>
                         <a:cs typeface="Montserrat" charset="0"/>
@@ -17692,7 +17754,7 @@
                         <a:buNone/>
                       </a:pPr>
                       <a:r>
-                        <a:rPr lang="en-US" sz="950" b="1" dirty="0">
+                        <a:rPr lang="en-US" sz="1150" b="1" dirty="0">
                           <a:solidFill>
                             <a:srgbClr val="16181D"/>
                           </a:solidFill>
@@ -17702,7 +17764,7 @@
                         </a:rPr>
                         <a:t>Token budgeting</a:t>
                       </a:r>
-                      <a:endParaRPr lang="en-US" sz="950" dirty="0">
+                      <a:endParaRPr lang="en-US" sz="1150" dirty="0">
                         <a:latin typeface="Montserrat" charset="0"/>
                         <a:ea typeface="Montserrat" charset="0"/>
                         <a:cs typeface="Montserrat" charset="0"/>
@@ -17760,7 +17822,7 @@
                         <a:buNone/>
                       </a:pPr>
                       <a:r>
-                        <a:rPr lang="en-US" sz="950" dirty="0">
+                        <a:rPr lang="en-US" sz="1150" dirty="0">
                           <a:solidFill>
                             <a:srgbClr val="16181D"/>
                           </a:solidFill>
@@ -17770,7 +17832,7 @@
                         </a:rPr>
                         <a:t>Allocate a budget per step by difficulty</a:t>
                       </a:r>
-                      <a:endParaRPr lang="en-US" sz="950" dirty="0">
+                      <a:endParaRPr lang="en-US" sz="1150" dirty="0">
                         <a:latin typeface="Montserrat" charset="0"/>
                         <a:ea typeface="Montserrat" charset="0"/>
                         <a:cs typeface="Montserrat" charset="0"/>
@@ -17828,7 +17890,7 @@
                         <a:buNone/>
                       </a:pPr>
                       <a:r>
-                        <a:rPr lang="en-US" sz="950" dirty="0">
+                        <a:rPr lang="en-US" sz="1150" dirty="0">
                           <a:solidFill>
                             <a:srgbClr val="16181D"/>
                           </a:solidFill>
@@ -17838,7 +17900,7 @@
                         </a:rPr>
                         <a:t>Adaptive depth, less overthinking</a:t>
                       </a:r>
-                      <a:endParaRPr lang="en-US" sz="950" dirty="0">
+                      <a:endParaRPr lang="en-US" sz="1150" dirty="0">
                         <a:latin typeface="Montserrat" charset="0"/>
                         <a:ea typeface="Montserrat" charset="0"/>
                         <a:cs typeface="Montserrat" charset="0"/>
@@ -17913,18 +17975,18 @@
           <a:bodyPr wrap="square" lIns="0" tIns="0" rIns="0" bIns="0" rtlCol="0" anchor="ctr"/>
           <a:lstStyle/>
           <a:p>
-            <a:pPr marL="342900" indent="-342900">
+            <a:pPr marL="127000" indent="-127000">
               <a:lnSpc>
-                <a:spcPct val="110000"/>
+                <a:spcPct val="104000"/>
               </a:lnSpc>
               <a:spcAft>
-                <a:spcPts val="700"/>
+                <a:spcPts val="400"/>
               </a:spcAft>
               <a:buSzPct val="100000"/>
               <a:buChar char="•"/>
             </a:pPr>
             <a:r>
-              <a:rPr lang="en-US" sz="1150" dirty="0">
+              <a:rPr lang="en-US" sz="1400" dirty="0">
                 <a:solidFill>
                   <a:srgbClr val="16181D"/>
                 </a:solidFill>
@@ -17934,21 +17996,21 @@
               </a:rPr>
               <a:t>Every method above shortens the CONTENT of a reasoning step.</a:t>
             </a:r>
-            <a:endParaRPr lang="en-US" sz="1150" dirty="0"/>
+            <a:endParaRPr lang="en-US" sz="1400" dirty="0"/>
           </a:p>
           <a:p>
-            <a:pPr marL="342900" indent="-342900">
+            <a:pPr marL="127000" indent="-127000">
               <a:lnSpc>
-                <a:spcPct val="110000"/>
+                <a:spcPct val="104000"/>
               </a:lnSpc>
               <a:spcAft>
-                <a:spcPts val="700"/>
+                <a:spcPts val="400"/>
               </a:spcAft>
               <a:buSzPct val="100000"/>
               <a:buChar char="•"/>
             </a:pPr>
             <a:r>
-              <a:rPr lang="en-US" sz="1150" dirty="0">
+              <a:rPr lang="en-US" sz="1400" dirty="0">
                 <a:solidFill>
                   <a:srgbClr val="16181D"/>
                 </a:solidFill>
@@ -17958,21 +18020,21 @@
               </a:rPr>
               <a:t>None reduces the NUMBER of steps, because a chain has no structure to remove.</a:t>
             </a:r>
-            <a:endParaRPr lang="en-US" sz="1150" dirty="0"/>
+            <a:endParaRPr lang="en-US" sz="1400" dirty="0"/>
           </a:p>
           <a:p>
-            <a:pPr marL="342900" indent="-342900">
+            <a:pPr marL="127000" indent="-127000">
               <a:lnSpc>
-                <a:spcPct val="110000"/>
+                <a:spcPct val="104000"/>
               </a:lnSpc>
               <a:spcAft>
-                <a:spcPts val="700"/>
+                <a:spcPts val="400"/>
               </a:spcAft>
               <a:buSzPct val="100000"/>
               <a:buChar char="•"/>
             </a:pPr>
             <a:r>
-              <a:rPr lang="en-US" sz="1150" dirty="0">
+              <a:rPr lang="en-US" sz="1400" dirty="0">
                 <a:solidFill>
                   <a:srgbClr val="16181D"/>
                 </a:solidFill>
@@ -17982,7 +18044,7 @@
               </a:rPr>
               <a:t>A graph does - and that is the gap this project occupies.</a:t>
             </a:r>
-            <a:endParaRPr lang="en-US" sz="1150" dirty="0"/>
+            <a:endParaRPr lang="en-US" sz="1400" dirty="0"/>
           </a:p>
         </p:txBody>
       </p:sp>
@@ -18038,7 +18100,7 @@
               <a:buNone/>
             </a:pPr>
             <a:r>
-              <a:rPr lang="en-US" sz="1100" b="1" dirty="0">
+              <a:rPr lang="en-US" sz="1350" b="1" dirty="0">
                 <a:solidFill>
                   <a:srgbClr val="23408E"/>
                 </a:solidFill>
@@ -18048,7 +18110,7 @@
               </a:rPr>
               <a:t>Two independent factors</a:t>
             </a:r>
-            <a:endParaRPr lang="en-US" sz="1100" dirty="0"/>
+            <a:endParaRPr lang="en-US" sz="1350" dirty="0"/>
           </a:p>
         </p:txBody>
       </p:sp>
@@ -18313,7 +18375,7 @@
               <a:buNone/>
             </a:pPr>
             <a:r>
-              <a:rPr lang="en-US" sz="900" i="1" dirty="0">
+              <a:rPr lang="en-US" sz="1050" i="1" dirty="0">
                 <a:solidFill>
                   <a:srgbClr val="63697A"/>
                 </a:solidFill>
@@ -18323,7 +18385,7 @@
               </a:rPr>
               <a:t>Xu et al. arXiv:2502.18600  |  Xia et al. arXiv:2502.12067  |  Hao et al. arXiv:2412.06769</a:t>
             </a:r>
-            <a:endParaRPr lang="en-US" sz="900" dirty="0"/>
+            <a:endParaRPr lang="en-US" sz="1050" dirty="0"/>
           </a:p>
         </p:txBody>
       </p:sp>
@@ -18600,18 +18662,18 @@
           <a:bodyPr wrap="square" lIns="0" tIns="0" rIns="0" bIns="0" rtlCol="0" anchor="ctr"/>
           <a:lstStyle/>
           <a:p>
-            <a:pPr marL="342900" indent="-342900">
+            <a:pPr marL="127000" indent="-127000">
               <a:lnSpc>
-                <a:spcPct val="110000"/>
+                <a:spcPct val="104000"/>
               </a:lnSpc>
               <a:spcAft>
-                <a:spcPts val="700"/>
+                <a:spcPts val="400"/>
               </a:spcAft>
               <a:buSzPct val="100000"/>
               <a:buChar char="•"/>
             </a:pPr>
             <a:r>
-              <a:rPr lang="en-US" sz="1250" dirty="0">
+              <a:rPr lang="en-US" sz="1400" dirty="0">
                 <a:solidFill>
                   <a:srgbClr val="16181D"/>
                 </a:solidFill>
@@ -18621,21 +18683,21 @@
               </a:rPr>
               <a:t>Faithful replication of Graph of Thoughts on open-weights models, with all four baselines on one engine</a:t>
             </a:r>
-            <a:endParaRPr lang="en-US" sz="1250" dirty="0"/>
+            <a:endParaRPr lang="en-US" sz="1400" dirty="0"/>
           </a:p>
           <a:p>
-            <a:pPr marL="342900" indent="-342900">
+            <a:pPr marL="127000" indent="-127000">
               <a:lnSpc>
-                <a:spcPct val="110000"/>
+                <a:spcPct val="104000"/>
               </a:lnSpc>
               <a:spcAft>
-                <a:spcPts val="700"/>
+                <a:spcPts val="400"/>
               </a:spcAft>
               <a:buSzPct val="100000"/>
               <a:buChar char="•"/>
             </a:pPr>
             <a:r>
-              <a:rPr lang="en-US" sz="1250" dirty="0">
+              <a:rPr lang="en-US" sz="1400" dirty="0">
                 <a:solidFill>
                   <a:srgbClr val="16181D"/>
                 </a:solidFill>
@@ -18645,21 +18707,21 @@
               </a:rPr>
               <a:t>Verification of the structural claims - volume, latency, aggregation count - independently of model quality</a:t>
             </a:r>
-            <a:endParaRPr lang="en-US" sz="1250" dirty="0"/>
+            <a:endParaRPr lang="en-US" sz="1400" dirty="0"/>
           </a:p>
           <a:p>
-            <a:pPr marL="342900" indent="-342900">
+            <a:pPr marL="127000" indent="-127000">
               <a:lnSpc>
-                <a:spcPct val="110000"/>
+                <a:spcPct val="104000"/>
               </a:lnSpc>
               <a:spcAft>
-                <a:spcPts val="700"/>
+                <a:spcPts val="400"/>
               </a:spcAft>
               <a:buSzPct val="100000"/>
               <a:buChar char="•"/>
             </a:pPr>
             <a:r>
-              <a:rPr lang="en-US" sz="1250" dirty="0">
+              <a:rPr lang="en-US" sz="1400" dirty="0">
                 <a:solidFill>
                   <a:srgbClr val="16181D"/>
                 </a:solidFill>
@@ -18669,21 +18731,21 @@
               </a:rPr>
               <a:t>Measurement of where the cost of a reasoning graph actually accumulates</a:t>
             </a:r>
-            <a:endParaRPr lang="en-US" sz="1250" dirty="0"/>
+            <a:endParaRPr lang="en-US" sz="1400" dirty="0"/>
           </a:p>
           <a:p>
-            <a:pPr marL="342900" indent="-342900">
+            <a:pPr marL="127000" indent="-127000">
               <a:lnSpc>
-                <a:spcPct val="110000"/>
+                <a:spcPct val="104000"/>
               </a:lnSpc>
               <a:spcAft>
-                <a:spcPts val="700"/>
+                <a:spcPts val="400"/>
               </a:spcAft>
               <a:buSzPct val="100000"/>
               <a:buChar char="•"/>
             </a:pPr>
             <a:r>
-              <a:rPr lang="en-US" sz="1250" dirty="0">
+              <a:rPr lang="en-US" sz="1400" dirty="0">
                 <a:solidFill>
                   <a:srgbClr val="16181D"/>
                 </a:solidFill>
@@ -18693,21 +18755,21 @@
               </a:rPr>
               <a:t>Application of chain-of-thought compression to the content of each vertex</a:t>
             </a:r>
-            <a:endParaRPr lang="en-US" sz="1250" dirty="0"/>
+            <a:endParaRPr lang="en-US" sz="1400" dirty="0"/>
           </a:p>
           <a:p>
-            <a:pPr marL="342900" indent="-342900">
+            <a:pPr marL="127000" indent="-127000">
               <a:lnSpc>
-                <a:spcPct val="110000"/>
+                <a:spcPct val="104000"/>
               </a:lnSpc>
               <a:spcAft>
-                <a:spcPts val="700"/>
+                <a:spcPts val="400"/>
               </a:spcAft>
               <a:buSzPct val="100000"/>
               <a:buChar char="•"/>
             </a:pPr>
             <a:r>
-              <a:rPr lang="en-US" sz="1250" dirty="0">
+              <a:rPr lang="en-US" sz="1400" dirty="0">
                 <a:solidFill>
                   <a:srgbClr val="16181D"/>
                 </a:solidFill>
@@ -18717,21 +18779,21 @@
               </a:rPr>
               <a:t>Development of a causality-preserving coarsening operator that reduces the number of vertices</a:t>
             </a:r>
-            <a:endParaRPr lang="en-US" sz="1250" dirty="0"/>
+            <a:endParaRPr lang="en-US" sz="1400" dirty="0"/>
           </a:p>
           <a:p>
-            <a:pPr marL="342900" indent="-342900">
+            <a:pPr marL="127000" indent="-127000">
               <a:lnSpc>
-                <a:spcPct val="110000"/>
+                <a:spcPct val="104000"/>
               </a:lnSpc>
               <a:spcAft>
-                <a:spcPts val="700"/>
+                <a:spcPts val="400"/>
               </a:spcAft>
               <a:buSzPct val="100000"/>
               <a:buChar char="•"/>
             </a:pPr>
             <a:r>
-              <a:rPr lang="en-US" sz="1250" dirty="0">
+              <a:rPr lang="en-US" sz="1400" dirty="0">
                 <a:solidFill>
                   <a:srgbClr val="16181D"/>
                 </a:solidFill>
@@ -18741,7 +18803,7 @@
               </a:rPr>
               <a:t>Evaluation of the compressed graph against the Tree of Thoughts cost-quality frontier</a:t>
             </a:r>
-            <a:endParaRPr lang="en-US" sz="1250" dirty="0"/>
+            <a:endParaRPr lang="en-US" sz="1400" dirty="0"/>
           </a:p>
         </p:txBody>
       </p:sp>
@@ -18797,7 +18859,7 @@
               <a:buNone/>
             </a:pPr>
             <a:r>
-              <a:rPr lang="en-US" sz="1150" b="1" dirty="0">
+              <a:rPr lang="en-US" sz="1300" b="1" dirty="0">
                 <a:solidFill>
                   <a:srgbClr val="23408E"/>
                 </a:solidFill>
@@ -18807,7 +18869,7 @@
               </a:rPr>
               <a:t>Status at mid-term</a:t>
             </a:r>
-            <a:endParaRPr lang="en-US" sz="1150" dirty="0"/>
+            <a:endParaRPr lang="en-US" sz="1300" dirty="0"/>
           </a:p>
         </p:txBody>
       </p:sp>
@@ -18861,7 +18923,7 @@
               <a:buNone/>
             </a:pPr>
             <a:r>
-              <a:rPr lang="en-US" sz="950" dirty="0">
+              <a:rPr lang="en-US" sz="1300" dirty="0">
                 <a:solidFill>
                   <a:srgbClr val="16181D"/>
                 </a:solidFill>
@@ -18871,7 +18933,7 @@
               </a:rPr>
               <a:t>Replication framework</a:t>
             </a:r>
-            <a:endParaRPr lang="en-US" sz="950" dirty="0"/>
+            <a:endParaRPr lang="en-US" sz="1300" dirty="0"/>
           </a:p>
         </p:txBody>
       </p:sp>
@@ -18900,7 +18962,7 @@
               <a:buNone/>
             </a:pPr>
             <a:r>
-              <a:rPr lang="en-US" sz="850" b="1" dirty="0">
+              <a:rPr lang="en-US" sz="1000" b="1" dirty="0">
                 <a:solidFill>
                   <a:srgbClr val="0F7B6C"/>
                 </a:solidFill>
@@ -18910,7 +18972,7 @@
               </a:rPr>
               <a:t>done</a:t>
             </a:r>
-            <a:endParaRPr lang="en-US" sz="850" dirty="0"/>
+            <a:endParaRPr lang="en-US" sz="1000" dirty="0"/>
           </a:p>
         </p:txBody>
       </p:sp>
@@ -18964,7 +19026,7 @@
               <a:buNone/>
             </a:pPr>
             <a:r>
-              <a:rPr lang="en-US" sz="950" dirty="0">
+              <a:rPr lang="en-US" sz="1300" dirty="0">
                 <a:solidFill>
                   <a:srgbClr val="16181D"/>
                 </a:solidFill>
@@ -18974,7 +19036,7 @@
               </a:rPr>
               <a:t>Structural verification</a:t>
             </a:r>
-            <a:endParaRPr lang="en-US" sz="950" dirty="0"/>
+            <a:endParaRPr lang="en-US" sz="1300" dirty="0"/>
           </a:p>
         </p:txBody>
       </p:sp>
@@ -19003,7 +19065,7 @@
               <a:buNone/>
             </a:pPr>
             <a:r>
-              <a:rPr lang="en-US" sz="850" b="1" dirty="0">
+              <a:rPr lang="en-US" sz="1000" b="1" dirty="0">
                 <a:solidFill>
                   <a:srgbClr val="0F7B6C"/>
                 </a:solidFill>
@@ -19013,7 +19075,7 @@
               </a:rPr>
               <a:t>done</a:t>
             </a:r>
-            <a:endParaRPr lang="en-US" sz="850" dirty="0"/>
+            <a:endParaRPr lang="en-US" sz="1000" dirty="0"/>
           </a:p>
         </p:txBody>
       </p:sp>
@@ -19067,7 +19129,7 @@
               <a:buNone/>
             </a:pPr>
             <a:r>
-              <a:rPr lang="en-US" sz="950" dirty="0">
+              <a:rPr lang="en-US" sz="1300" dirty="0">
                 <a:solidFill>
                   <a:srgbClr val="16181D"/>
                 </a:solidFill>
@@ -19077,7 +19139,7 @@
               </a:rPr>
               <a:t>Cost characterisation</a:t>
             </a:r>
-            <a:endParaRPr lang="en-US" sz="950" dirty="0"/>
+            <a:endParaRPr lang="en-US" sz="1300" dirty="0"/>
           </a:p>
         </p:txBody>
       </p:sp>
@@ -19106,7 +19168,7 @@
               <a:buNone/>
             </a:pPr>
             <a:r>
-              <a:rPr lang="en-US" sz="850" b="1" dirty="0">
+              <a:rPr lang="en-US" sz="1000" b="1" dirty="0">
                 <a:solidFill>
                   <a:srgbClr val="0F7B6C"/>
                 </a:solidFill>
@@ -19116,7 +19178,7 @@
               </a:rPr>
               <a:t>done</a:t>
             </a:r>
-            <a:endParaRPr lang="en-US" sz="850" dirty="0"/>
+            <a:endParaRPr lang="en-US" sz="1000" dirty="0"/>
           </a:p>
         </p:txBody>
       </p:sp>
@@ -19170,7 +19232,7 @@
               <a:buNone/>
             </a:pPr>
             <a:r>
-              <a:rPr lang="en-US" sz="950" dirty="0">
+              <a:rPr lang="en-US" sz="1300" dirty="0">
                 <a:solidFill>
                   <a:srgbClr val="16181D"/>
                 </a:solidFill>
@@ -19180,7 +19242,7 @@
               </a:rPr>
               <a:t>Naive-compression study</a:t>
             </a:r>
-            <a:endParaRPr lang="en-US" sz="950" dirty="0"/>
+            <a:endParaRPr lang="en-US" sz="1300" dirty="0"/>
           </a:p>
         </p:txBody>
       </p:sp>
@@ -19209,7 +19271,7 @@
               <a:buNone/>
             </a:pPr>
             <a:r>
-              <a:rPr lang="en-US" sz="850" b="1" dirty="0">
+              <a:rPr lang="en-US" sz="1000" b="1" dirty="0">
                 <a:solidFill>
                   <a:srgbClr val="0F7B6C"/>
                 </a:solidFill>
@@ -19219,7 +19281,7 @@
               </a:rPr>
               <a:t>done</a:t>
             </a:r>
-            <a:endParaRPr lang="en-US" sz="850" dirty="0"/>
+            <a:endParaRPr lang="en-US" sz="1000" dirty="0"/>
           </a:p>
         </p:txBody>
       </p:sp>
@@ -19273,7 +19335,7 @@
               <a:buNone/>
             </a:pPr>
             <a:r>
-              <a:rPr lang="en-US" sz="950" dirty="0">
+              <a:rPr lang="en-US" sz="1300" dirty="0">
                 <a:solidFill>
                   <a:srgbClr val="16181D"/>
                 </a:solidFill>
@@ -19283,7 +19345,7 @@
               </a:rPr>
               <a:t>Vertex compression</a:t>
             </a:r>
-            <a:endParaRPr lang="en-US" sz="950" dirty="0"/>
+            <a:endParaRPr lang="en-US" sz="1300" dirty="0"/>
           </a:p>
         </p:txBody>
       </p:sp>
@@ -19312,7 +19374,7 @@
               <a:buNone/>
             </a:pPr>
             <a:r>
-              <a:rPr lang="en-US" sz="850" b="1" dirty="0">
+              <a:rPr lang="en-US" sz="1000" b="1" dirty="0">
                 <a:solidFill>
                   <a:srgbClr val="D98A1F"/>
                 </a:solidFill>
@@ -19322,7 +19384,7 @@
               </a:rPr>
               <a:t>in progress</a:t>
             </a:r>
-            <a:endParaRPr lang="en-US" sz="850" dirty="0"/>
+            <a:endParaRPr lang="en-US" sz="1000" dirty="0"/>
           </a:p>
         </p:txBody>
       </p:sp>
@@ -19376,7 +19438,7 @@
               <a:buNone/>
             </a:pPr>
             <a:r>
-              <a:rPr lang="en-US" sz="950" dirty="0">
+              <a:rPr lang="en-US" sz="1300" dirty="0">
                 <a:solidFill>
                   <a:srgbClr val="16181D"/>
                 </a:solidFill>
@@ -19386,7 +19448,7 @@
               </a:rPr>
               <a:t>Coarsening operator</a:t>
             </a:r>
-            <a:endParaRPr lang="en-US" sz="950" dirty="0"/>
+            <a:endParaRPr lang="en-US" sz="1300" dirty="0"/>
           </a:p>
         </p:txBody>
       </p:sp>
@@ -19415,7 +19477,7 @@
               <a:buNone/>
             </a:pPr>
             <a:r>
-              <a:rPr lang="en-US" sz="850" b="1" dirty="0">
+              <a:rPr lang="en-US" sz="1000" b="1" dirty="0">
                 <a:solidFill>
                   <a:srgbClr val="63697A"/>
                 </a:solidFill>
@@ -19425,7 +19487,7 @@
               </a:rPr>
               <a:t>planned</a:t>
             </a:r>
-            <a:endParaRPr lang="en-US" sz="850" dirty="0"/>
+            <a:endParaRPr lang="en-US" sz="1000" dirty="0"/>
           </a:p>
         </p:txBody>
       </p:sp>
@@ -19479,7 +19541,7 @@
               <a:buNone/>
             </a:pPr>
             <a:r>
-              <a:rPr lang="en-US" sz="950" dirty="0">
+              <a:rPr lang="en-US" sz="1300" dirty="0">
                 <a:solidFill>
                   <a:srgbClr val="16181D"/>
                 </a:solidFill>
@@ -19489,7 +19551,7 @@
               </a:rPr>
               <a:t>Frontier evaluation</a:t>
             </a:r>
-            <a:endParaRPr lang="en-US" sz="950" dirty="0"/>
+            <a:endParaRPr lang="en-US" sz="1300" dirty="0"/>
           </a:p>
         </p:txBody>
       </p:sp>
@@ -19518,7 +19580,7 @@
               <a:buNone/>
             </a:pPr>
             <a:r>
-              <a:rPr lang="en-US" sz="850" b="1" dirty="0">
+              <a:rPr lang="en-US" sz="1000" b="1" dirty="0">
                 <a:solidFill>
                   <a:srgbClr val="63697A"/>
                 </a:solidFill>
@@ -19528,7 +19590,7 @@
               </a:rPr>
               <a:t>planned</a:t>
             </a:r>
-            <a:endParaRPr lang="en-US" sz="850" dirty="0"/>
+            <a:endParaRPr lang="en-US" sz="1000" dirty="0"/>
           </a:p>
         </p:txBody>
       </p:sp>
@@ -19809,7 +19871,7 @@
               <a:buNone/>
             </a:pPr>
             <a:r>
-              <a:rPr lang="en-US" sz="1450" b="1" dirty="0">
+              <a:rPr lang="en-US" sz="1550" b="1" dirty="0">
                 <a:solidFill>
                   <a:srgbClr val="23408E"/>
                 </a:solidFill>
@@ -19819,7 +19881,7 @@
               </a:rPr>
               <a:t>1) How the reasoning graph constructs its vertices and edges</a:t>
             </a:r>
-            <a:endParaRPr lang="en-US" sz="1450" dirty="0"/>
+            <a:endParaRPr lang="en-US" sz="1550" dirty="0"/>
           </a:p>
         </p:txBody>
       </p:sp>
@@ -19914,7 +19976,7 @@
               <a:buNone/>
             </a:pPr>
             <a:r>
-              <a:rPr lang="en-US" sz="950" dirty="0">
+              <a:rPr lang="en-US" sz="1300" dirty="0">
                 <a:solidFill>
                   <a:srgbClr val="16181D"/>
                 </a:solidFill>
@@ -19924,14 +19986,14 @@
               </a:rPr>
               <a:t>for op in TOPOLOGICAL-ORDER(GoO):</a:t>
             </a:r>
-            <a:endParaRPr lang="en-US" sz="950" dirty="0"/>
+            <a:endParaRPr lang="en-US" sz="1300" dirty="0"/>
           </a:p>
           <a:p>
             <a:pPr indent="0" marL="0">
               <a:buNone/>
             </a:pPr>
             <a:r>
-              <a:rPr lang="en-US" sz="950" dirty="0">
+              <a:rPr lang="en-US" sz="1300" dirty="0">
                 <a:solidFill>
                   <a:srgbClr val="16181D"/>
                 </a:solidFill>
@@ -19941,14 +20003,14 @@
               </a:rPr>
               <a:t>   parents &lt;- thoughts of op.predecessors</a:t>
             </a:r>
-            <a:endParaRPr lang="en-US" sz="950" dirty="0"/>
+            <a:endParaRPr lang="en-US" sz="1300" dirty="0"/>
           </a:p>
           <a:p>
             <a:pPr indent="0" marL="0">
               <a:buNone/>
             </a:pPr>
             <a:r>
-              <a:rPr lang="en-US" sz="950" dirty="0">
+              <a:rPr lang="en-US" sz="1300" dirty="0">
                 <a:solidFill>
                   <a:srgbClr val="16181D"/>
                 </a:solidFill>
@@ -19958,14 +20020,14 @@
               </a:rPr>
               <a:t>   for t in op.EXECUTE(parents):</a:t>
             </a:r>
-            <a:endParaRPr lang="en-US" sz="950" dirty="0"/>
+            <a:endParaRPr lang="en-US" sz="1300" dirty="0"/>
           </a:p>
           <a:p>
             <a:pPr indent="0" marL="0">
               <a:buNone/>
             </a:pPr>
             <a:r>
-              <a:rPr lang="en-US" sz="950" dirty="0">
+              <a:rPr lang="en-US" sz="1300" dirty="0">
                 <a:solidFill>
                   <a:srgbClr val="16181D"/>
                 </a:solidFill>
@@ -19975,14 +20037,14 @@
               </a:rPr>
               <a:t>      V &lt;- V + { t }</a:t>
             </a:r>
-            <a:endParaRPr lang="en-US" sz="950" dirty="0"/>
+            <a:endParaRPr lang="en-US" sz="1300" dirty="0"/>
           </a:p>
           <a:p>
             <a:pPr indent="0" marL="0">
               <a:buNone/>
             </a:pPr>
             <a:r>
-              <a:rPr lang="en-US" sz="950" dirty="0">
+              <a:rPr lang="en-US" sz="1300" dirty="0">
                 <a:solidFill>
                   <a:srgbClr val="16181D"/>
                 </a:solidFill>
@@ -19992,14 +20054,14 @@
               </a:rPr>
               <a:t>      for p in t.parents:</a:t>
             </a:r>
-            <a:endParaRPr lang="en-US" sz="950" dirty="0"/>
+            <a:endParaRPr lang="en-US" sz="1300" dirty="0"/>
           </a:p>
           <a:p>
             <a:pPr indent="0" marL="0">
               <a:buNone/>
             </a:pPr>
             <a:r>
-              <a:rPr lang="en-US" sz="950" dirty="0">
+              <a:rPr lang="en-US" sz="1300" dirty="0">
                 <a:solidFill>
                   <a:srgbClr val="16181D"/>
                 </a:solidFill>
@@ -20009,7 +20071,7 @@
               </a:rPr>
               <a:t>         E &lt;- E + { (p, t) }</a:t>
             </a:r>
-            <a:endParaRPr lang="en-US" sz="950" dirty="0"/>
+            <a:endParaRPr lang="en-US" sz="1300" dirty="0"/>
           </a:p>
         </p:txBody>
       </p:sp>
@@ -20050,7 +20112,7 @@
                         <a:buNone/>
                       </a:pPr>
                       <a:r>
-                        <a:rPr lang="en-US" sz="950" b="1" dirty="0">
+                        <a:rPr lang="en-US" sz="1150" b="1" dirty="0">
                           <a:solidFill>
                             <a:srgbClr val="FFFFFF"/>
                           </a:solidFill>
@@ -20060,7 +20122,7 @@
                         </a:rPr>
                         <a:t>Operation</a:t>
                       </a:r>
-                      <a:endParaRPr lang="en-US" sz="950" dirty="0">
+                      <a:endParaRPr lang="en-US" sz="1150" dirty="0">
                         <a:latin typeface="Montserrat" charset="0"/>
                         <a:ea typeface="Montserrat" charset="0"/>
                         <a:cs typeface="Montserrat" charset="0"/>
@@ -20118,7 +20180,7 @@
                         <a:buNone/>
                       </a:pPr>
                       <a:r>
-                        <a:rPr lang="en-US" sz="950" b="1" dirty="0">
+                        <a:rPr lang="en-US" sz="1150" b="1" dirty="0">
                           <a:solidFill>
                             <a:srgbClr val="FFFFFF"/>
                           </a:solidFill>
@@ -20128,7 +20190,7 @@
                         </a:rPr>
                         <a:t>Vertices</a:t>
                       </a:r>
-                      <a:endParaRPr lang="en-US" sz="950" dirty="0">
+                      <a:endParaRPr lang="en-US" sz="1150" dirty="0">
                         <a:latin typeface="Montserrat" charset="0"/>
                         <a:ea typeface="Montserrat" charset="0"/>
                         <a:cs typeface="Montserrat" charset="0"/>
@@ -20186,7 +20248,7 @@
                         <a:buNone/>
                       </a:pPr>
                       <a:r>
-                        <a:rPr lang="en-US" sz="950" b="1" dirty="0">
+                        <a:rPr lang="en-US" sz="1150" b="1" dirty="0">
                           <a:solidFill>
                             <a:srgbClr val="FFFFFF"/>
                           </a:solidFill>
@@ -20196,7 +20258,7 @@
                         </a:rPr>
                         <a:t>Edges</a:t>
                       </a:r>
-                      <a:endParaRPr lang="en-US" sz="950" dirty="0">
+                      <a:endParaRPr lang="en-US" sz="1150" dirty="0">
                         <a:latin typeface="Montserrat" charset="0"/>
                         <a:ea typeface="Montserrat" charset="0"/>
                         <a:cs typeface="Montserrat" charset="0"/>
@@ -20256,7 +20318,7 @@
                         <a:buNone/>
                       </a:pPr>
                       <a:r>
-                        <a:rPr lang="en-US" sz="950" b="1" dirty="0">
+                        <a:rPr lang="en-US" sz="1150" b="1" dirty="0">
                           <a:solidFill>
                             <a:srgbClr val="16181D"/>
                           </a:solidFill>
@@ -20266,7 +20328,7 @@
                         </a:rPr>
                         <a:t>Generate (k)</a:t>
                       </a:r>
-                      <a:endParaRPr lang="en-US" sz="950" dirty="0">
+                      <a:endParaRPr lang="en-US" sz="1150" dirty="0">
                         <a:latin typeface="Montserrat" charset="0"/>
                         <a:ea typeface="Montserrat" charset="0"/>
                         <a:cs typeface="Montserrat" charset="0"/>
@@ -20324,7 +20386,7 @@
                         <a:buNone/>
                       </a:pPr>
                       <a:r>
-                        <a:rPr lang="en-US" sz="950" dirty="0">
+                        <a:rPr lang="en-US" sz="1150" dirty="0">
                           <a:solidFill>
                             <a:srgbClr val="16181D"/>
                           </a:solidFill>
@@ -20334,7 +20396,7 @@
                         </a:rPr>
                         <a:t>k per input</a:t>
                       </a:r>
-                      <a:endParaRPr lang="en-US" sz="950" dirty="0">
+                      <a:endParaRPr lang="en-US" sz="1150" dirty="0">
                         <a:latin typeface="Montserrat" charset="0"/>
                         <a:ea typeface="Montserrat" charset="0"/>
                         <a:cs typeface="Montserrat" charset="0"/>
@@ -20392,7 +20454,7 @@
                         <a:buNone/>
                       </a:pPr>
                       <a:r>
-                        <a:rPr lang="en-US" sz="950" dirty="0">
+                        <a:rPr lang="en-US" sz="1150" dirty="0">
                           <a:solidFill>
                             <a:srgbClr val="16181D"/>
                           </a:solidFill>
@@ -20402,7 +20464,7 @@
                         </a:rPr>
                         <a:t>input -&gt; each new</a:t>
                       </a:r>
-                      <a:endParaRPr lang="en-US" sz="950" dirty="0">
+                      <a:endParaRPr lang="en-US" sz="1150" dirty="0">
                         <a:latin typeface="Montserrat" charset="0"/>
                         <a:ea typeface="Montserrat" charset="0"/>
                         <a:cs typeface="Montserrat" charset="0"/>
@@ -20462,7 +20524,7 @@
                         <a:buNone/>
                       </a:pPr>
                       <a:r>
-                        <a:rPr lang="en-US" sz="950" b="1" dirty="0">
+                        <a:rPr lang="en-US" sz="1150" b="1" dirty="0">
                           <a:solidFill>
                             <a:srgbClr val="D98A1F"/>
                           </a:solidFill>
@@ -20472,7 +20534,7 @@
                         </a:rPr>
                         <a:t>Aggregate (k)</a:t>
                       </a:r>
-                      <a:endParaRPr lang="en-US" sz="950" dirty="0">
+                      <a:endParaRPr lang="en-US" sz="1150" dirty="0">
                         <a:latin typeface="Montserrat" charset="0"/>
                         <a:ea typeface="Montserrat" charset="0"/>
                         <a:cs typeface="Montserrat" charset="0"/>
@@ -20530,7 +20592,7 @@
                         <a:buNone/>
                       </a:pPr>
                       <a:r>
-                        <a:rPr lang="en-US" sz="950" b="1" dirty="0">
+                        <a:rPr lang="en-US" sz="1150" b="1" dirty="0">
                           <a:solidFill>
                             <a:srgbClr val="D98A1F"/>
                           </a:solidFill>
@@ -20540,7 +20602,7 @@
                         </a:rPr>
                         <a:t>k, from all inputs</a:t>
                       </a:r>
-                      <a:endParaRPr lang="en-US" sz="950" dirty="0">
+                      <a:endParaRPr lang="en-US" sz="1150" dirty="0">
                         <a:latin typeface="Montserrat" charset="0"/>
                         <a:ea typeface="Montserrat" charset="0"/>
                         <a:cs typeface="Montserrat" charset="0"/>
@@ -20598,7 +20660,7 @@
                         <a:buNone/>
                       </a:pPr>
                       <a:r>
-                        <a:rPr lang="en-US" sz="950" b="1" dirty="0">
+                        <a:rPr lang="en-US" sz="1150" b="1" dirty="0">
                           <a:solidFill>
                             <a:srgbClr val="D98A1F"/>
                           </a:solidFill>
@@ -20608,7 +20670,7 @@
                         </a:rPr>
                         <a:t>EVERY input -&gt; each new</a:t>
                       </a:r>
-                      <a:endParaRPr lang="en-US" sz="950" dirty="0">
+                      <a:endParaRPr lang="en-US" sz="1150" dirty="0">
                         <a:latin typeface="Montserrat" charset="0"/>
                         <a:ea typeface="Montserrat" charset="0"/>
                         <a:cs typeface="Montserrat" charset="0"/>
@@ -20668,7 +20730,7 @@
                         <a:buNone/>
                       </a:pPr>
                       <a:r>
-                        <a:rPr lang="en-US" sz="950" b="1" dirty="0">
+                        <a:rPr lang="en-US" sz="1150" b="1" dirty="0">
                           <a:solidFill>
                             <a:srgbClr val="16181D"/>
                           </a:solidFill>
@@ -20678,7 +20740,7 @@
                         </a:rPr>
                         <a:t>Improve</a:t>
                       </a:r>
-                      <a:endParaRPr lang="en-US" sz="950" dirty="0">
+                      <a:endParaRPr lang="en-US" sz="1150" dirty="0">
                         <a:latin typeface="Montserrat" charset="0"/>
                         <a:ea typeface="Montserrat" charset="0"/>
                         <a:cs typeface="Montserrat" charset="0"/>
@@ -20736,7 +20798,7 @@
                         <a:buNone/>
                       </a:pPr>
                       <a:r>
-                        <a:rPr lang="en-US" sz="950" dirty="0">
+                        <a:rPr lang="en-US" sz="1150" dirty="0">
                           <a:solidFill>
                             <a:srgbClr val="16181D"/>
                           </a:solidFill>
@@ -20746,7 +20808,7 @@
                         </a:rPr>
                         <a:t>1 per input</a:t>
                       </a:r>
-                      <a:endParaRPr lang="en-US" sz="950" dirty="0">
+                      <a:endParaRPr lang="en-US" sz="1150" dirty="0">
                         <a:latin typeface="Montserrat" charset="0"/>
                         <a:ea typeface="Montserrat" charset="0"/>
                         <a:cs typeface="Montserrat" charset="0"/>
@@ -20804,7 +20866,7 @@
                         <a:buNone/>
                       </a:pPr>
                       <a:r>
-                        <a:rPr lang="en-US" sz="950" dirty="0">
+                        <a:rPr lang="en-US" sz="1150" dirty="0">
                           <a:solidFill>
                             <a:srgbClr val="16181D"/>
                           </a:solidFill>
@@ -20814,7 +20876,7 @@
                         </a:rPr>
                         <a:t>input -&gt; new</a:t>
                       </a:r>
-                      <a:endParaRPr lang="en-US" sz="950" dirty="0">
+                      <a:endParaRPr lang="en-US" sz="1150" dirty="0">
                         <a:latin typeface="Montserrat" charset="0"/>
                         <a:ea typeface="Montserrat" charset="0"/>
                         <a:cs typeface="Montserrat" charset="0"/>
@@ -20874,7 +20936,7 @@
                         <a:buNone/>
                       </a:pPr>
                       <a:r>
-                        <a:rPr lang="en-US" sz="950" b="1" dirty="0">
+                        <a:rPr lang="en-US" sz="1150" b="1" dirty="0">
                           <a:solidFill>
                             <a:srgbClr val="16181D"/>
                           </a:solidFill>
@@ -20884,7 +20946,7 @@
                         </a:rPr>
                         <a:t>Score</a:t>
                       </a:r>
-                      <a:endParaRPr lang="en-US" sz="950" dirty="0">
+                      <a:endParaRPr lang="en-US" sz="1150" dirty="0">
                         <a:latin typeface="Montserrat" charset="0"/>
                         <a:ea typeface="Montserrat" charset="0"/>
                         <a:cs typeface="Montserrat" charset="0"/>
@@ -20942,7 +21004,7 @@
                         <a:buNone/>
                       </a:pPr>
                       <a:r>
-                        <a:rPr lang="en-US" sz="950" dirty="0">
+                        <a:rPr lang="en-US" sz="1150" dirty="0">
                           <a:solidFill>
                             <a:srgbClr val="16181D"/>
                           </a:solidFill>
@@ -20952,7 +21014,7 @@
                         </a:rPr>
                         <a:t>none</a:t>
                       </a:r>
-                      <a:endParaRPr lang="en-US" sz="950" dirty="0">
+                      <a:endParaRPr lang="en-US" sz="1150" dirty="0">
                         <a:latin typeface="Montserrat" charset="0"/>
                         <a:ea typeface="Montserrat" charset="0"/>
                         <a:cs typeface="Montserrat" charset="0"/>
@@ -21010,7 +21072,7 @@
                         <a:buNone/>
                       </a:pPr>
                       <a:r>
-                        <a:rPr lang="en-US" sz="950" dirty="0">
+                        <a:rPr lang="en-US" sz="1150" dirty="0">
                           <a:solidFill>
                             <a:srgbClr val="16181D"/>
                           </a:solidFill>
@@ -21020,7 +21082,7 @@
                         </a:rPr>
                         <a:t>none</a:t>
                       </a:r>
-                      <a:endParaRPr lang="en-US" sz="950" dirty="0">
+                      <a:endParaRPr lang="en-US" sz="1150" dirty="0">
                         <a:latin typeface="Montserrat" charset="0"/>
                         <a:ea typeface="Montserrat" charset="0"/>
                         <a:cs typeface="Montserrat" charset="0"/>
@@ -21080,7 +21142,7 @@
                         <a:buNone/>
                       </a:pPr>
                       <a:r>
-                        <a:rPr lang="en-US" sz="950" b="1" dirty="0">
+                        <a:rPr lang="en-US" sz="1150" b="1" dirty="0">
                           <a:solidFill>
                             <a:srgbClr val="16181D"/>
                           </a:solidFill>
@@ -21090,7 +21152,7 @@
                         </a:rPr>
                         <a:t>KeepBest (n)</a:t>
                       </a:r>
-                      <a:endParaRPr lang="en-US" sz="950" dirty="0">
+                      <a:endParaRPr lang="en-US" sz="1150" dirty="0">
                         <a:latin typeface="Montserrat" charset="0"/>
                         <a:ea typeface="Montserrat" charset="0"/>
                         <a:cs typeface="Montserrat" charset="0"/>
@@ -21148,7 +21210,7 @@
                         <a:buNone/>
                       </a:pPr>
                       <a:r>
-                        <a:rPr lang="en-US" sz="950" dirty="0">
+                        <a:rPr lang="en-US" sz="1150" dirty="0">
                           <a:solidFill>
                             <a:srgbClr val="16181D"/>
                           </a:solidFill>
@@ -21158,7 +21220,7 @@
                         </a:rPr>
                         <a:t>none</a:t>
                       </a:r>
-                      <a:endParaRPr lang="en-US" sz="950" dirty="0">
+                      <a:endParaRPr lang="en-US" sz="1150" dirty="0">
                         <a:latin typeface="Montserrat" charset="0"/>
                         <a:ea typeface="Montserrat" charset="0"/>
                         <a:cs typeface="Montserrat" charset="0"/>
@@ -21216,7 +21278,7 @@
                         <a:buNone/>
                       </a:pPr>
                       <a:r>
-                        <a:rPr lang="en-US" sz="950" dirty="0">
+                        <a:rPr lang="en-US" sz="1150" dirty="0">
                           <a:solidFill>
                             <a:srgbClr val="16181D"/>
                           </a:solidFill>
@@ -21226,7 +21288,7 @@
                         </a:rPr>
                         <a:t>none</a:t>
                       </a:r>
-                      <a:endParaRPr lang="en-US" sz="950" dirty="0">
+                      <a:endParaRPr lang="en-US" sz="1150" dirty="0">
                         <a:latin typeface="Montserrat" charset="0"/>
                         <a:ea typeface="Montserrat" charset="0"/>
                         <a:cs typeface="Montserrat" charset="0"/>
@@ -21344,7 +21406,7 @@
               <a:buNone/>
             </a:pPr>
             <a:r>
-              <a:rPr lang="en-US" sz="1450" b="1" dirty="0">
+              <a:rPr lang="en-US" sz="1550" b="1" dirty="0">
                 <a:solidFill>
                   <a:srgbClr val="23408E"/>
                 </a:solidFill>
@@ -21354,7 +21416,7 @@
               </a:rPr>
               <a:t>2) The rule that defines the structure</a:t>
             </a:r>
-            <a:endParaRPr lang="en-US" sz="1450" dirty="0"/>
+            <a:endParaRPr lang="en-US" sz="1550" dirty="0"/>
           </a:p>
         </p:txBody>
       </p:sp>
@@ -21693,8 +21755,8 @@
         </p:nvSpPr>
         <p:spPr>
           <a:xfrm>
-            <a:off x="6400800" y="4480560"/>
-            <a:ext cx="4846320" cy="292608"/>
+            <a:off x="6400800" y="4443984"/>
+            <a:ext cx="4846320" cy="603504"/>
           </a:xfrm>
           <a:prstGeom prst="rect">
             <a:avLst/>
@@ -21710,7 +21772,7 @@
               <a:buNone/>
             </a:pPr>
             <a:r>
-              <a:rPr lang="en-US" sz="1100" b="1" dirty="0">
+              <a:rPr lang="en-US" sz="1350" b="1" dirty="0">
                 <a:solidFill>
                   <a:srgbClr val="23408E"/>
                 </a:solidFill>
@@ -21718,9 +21780,9 @@
                 <a:ea typeface="Montserrat" pitchFamily="34" charset="-122"/>
                 <a:cs typeface="Montserrat" pitchFamily="34" charset="-120"/>
               </a:rPr>
-              <a:t>An edge (a, b) means a's text was literally the input that produced b.</a:t>
+              <a:t>An edge (a, b) means a's text was the input that produced b.</a:t>
             </a:r>
-            <a:endParaRPr lang="en-US" sz="1100" dirty="0"/>
+            <a:endParaRPr lang="en-US" sz="1350" dirty="0"/>
           </a:p>
         </p:txBody>
       </p:sp>
@@ -21732,8 +21794,8 @@
         </p:nvSpPr>
         <p:spPr>
           <a:xfrm>
-            <a:off x="6400800" y="4846320"/>
-            <a:ext cx="4846320" cy="1051560"/>
+            <a:off x="6400800" y="5102352"/>
+            <a:ext cx="4846320" cy="868680"/>
           </a:xfrm>
           <a:prstGeom prst="rect">
             <a:avLst/>
@@ -21749,7 +21811,7 @@
               <a:buNone/>
             </a:pPr>
             <a:r>
-              <a:rPr lang="en-US" sz="1000" dirty="0">
+              <a:rPr lang="en-US" sz="1200" dirty="0">
                 <a:solidFill>
                   <a:srgbClr val="16181D"/>
                 </a:solidFill>
@@ -21759,7 +21821,7 @@
               </a:rPr>
               <a:t>Edges encode causality, not similarity. A coarsening operator therefore cannot merge vertices because they resemble one another - it must preserve which thoughts can still reach the answer.</a:t>
             </a:r>
-            <a:endParaRPr lang="en-US" sz="1000" dirty="0"/>
+            <a:endParaRPr lang="en-US" sz="1200" dirty="0"/>
           </a:p>
         </p:txBody>
       </p:sp>
@@ -22040,7 +22102,7 @@
               <a:buNone/>
             </a:pPr>
             <a:r>
-              <a:rPr lang="en-US" sz="1450" b="1" dirty="0">
+              <a:rPr lang="en-US" sz="1550" b="1" dirty="0">
                 <a:solidFill>
                   <a:srgbClr val="23408E"/>
                 </a:solidFill>
@@ -22050,7 +22112,7 @@
               </a:rPr>
               <a:t>3) Datasets - synthetic, with computed ground truth</a:t>
             </a:r>
-            <a:endParaRPr lang="en-US" sz="1450" dirty="0"/>
+            <a:endParaRPr lang="en-US" sz="1550" dirty="0"/>
           </a:p>
         </p:txBody>
       </p:sp>
@@ -22092,7 +22154,7 @@
                         <a:buNone/>
                       </a:pPr>
                       <a:r>
-                        <a:rPr lang="en-US" sz="950" b="1" dirty="0">
+                        <a:rPr lang="en-US" sz="1150" b="1" dirty="0">
                           <a:solidFill>
                             <a:srgbClr val="FFFFFF"/>
                           </a:solidFill>
@@ -22102,7 +22164,7 @@
                         </a:rPr>
                         <a:t>Task</a:t>
                       </a:r>
-                      <a:endParaRPr lang="en-US" sz="950" dirty="0">
+                      <a:endParaRPr lang="en-US" sz="1150" dirty="0">
                         <a:latin typeface="Montserrat" charset="0"/>
                         <a:ea typeface="Montserrat" charset="0"/>
                         <a:cs typeface="Montserrat" charset="0"/>
@@ -22160,7 +22222,7 @@
                         <a:buNone/>
                       </a:pPr>
                       <a:r>
-                        <a:rPr lang="en-US" sz="950" b="1" dirty="0">
+                        <a:rPr lang="en-US" sz="1150" b="1" dirty="0">
                           <a:solidFill>
                             <a:srgbClr val="FFFFFF"/>
                           </a:solidFill>
@@ -22170,7 +22232,7 @@
                         </a:rPr>
                         <a:t>Input</a:t>
                       </a:r>
-                      <a:endParaRPr lang="en-US" sz="950" dirty="0">
+                      <a:endParaRPr lang="en-US" sz="1150" dirty="0">
                         <a:latin typeface="Montserrat" charset="0"/>
                         <a:ea typeface="Montserrat" charset="0"/>
                         <a:cs typeface="Montserrat" charset="0"/>
@@ -22228,7 +22290,7 @@
                         <a:buNone/>
                       </a:pPr>
                       <a:r>
-                        <a:rPr lang="en-US" sz="950" b="1" dirty="0">
+                        <a:rPr lang="en-US" sz="1150" b="1" dirty="0">
                           <a:solidFill>
                             <a:srgbClr val="FFFFFF"/>
                           </a:solidFill>
@@ -22238,7 +22300,7 @@
                         </a:rPr>
                         <a:t>Sizes</a:t>
                       </a:r>
-                      <a:endParaRPr lang="en-US" sz="950" dirty="0">
+                      <a:endParaRPr lang="en-US" sz="1150" dirty="0">
                         <a:latin typeface="Montserrat" charset="0"/>
                         <a:ea typeface="Montserrat" charset="0"/>
                         <a:cs typeface="Montserrat" charset="0"/>
@@ -22296,7 +22358,7 @@
                         <a:buNone/>
                       </a:pPr>
                       <a:r>
-                        <a:rPr lang="en-US" sz="950" b="1" dirty="0">
+                        <a:rPr lang="en-US" sz="1150" b="1" dirty="0">
                           <a:solidFill>
                             <a:srgbClr val="FFFFFF"/>
                           </a:solidFill>
@@ -22306,7 +22368,7 @@
                         </a:rPr>
                         <a:t>Instances</a:t>
                       </a:r>
-                      <a:endParaRPr lang="en-US" sz="950" dirty="0">
+                      <a:endParaRPr lang="en-US" sz="1150" dirty="0">
                         <a:latin typeface="Montserrat" charset="0"/>
                         <a:ea typeface="Montserrat" charset="0"/>
                         <a:cs typeface="Montserrat" charset="0"/>
@@ -22366,7 +22428,7 @@
                         <a:buNone/>
                       </a:pPr>
                       <a:r>
-                        <a:rPr lang="en-US" sz="950" b="1" dirty="0">
+                        <a:rPr lang="en-US" sz="1150" b="1" dirty="0">
                           <a:solidFill>
                             <a:srgbClr val="16181D"/>
                           </a:solidFill>
@@ -22376,7 +22438,7 @@
                         </a:rPr>
                         <a:t>Sorting</a:t>
                       </a:r>
-                      <a:endParaRPr lang="en-US" sz="950" dirty="0">
+                      <a:endParaRPr lang="en-US" sz="1150" dirty="0">
                         <a:latin typeface="Montserrat" charset="0"/>
                         <a:ea typeface="Montserrat" charset="0"/>
                         <a:cs typeface="Montserrat" charset="0"/>
@@ -22434,7 +22496,7 @@
                         <a:buNone/>
                       </a:pPr>
                       <a:r>
-                        <a:rPr lang="en-US" sz="950" dirty="0">
+                        <a:rPr lang="en-US" sz="1150" dirty="0">
                           <a:solidFill>
                             <a:srgbClr val="16181D"/>
                           </a:solidFill>
@@ -22444,7 +22506,7 @@
                         </a:rPr>
                         <a:t>digits 0-9 with duplicates</a:t>
                       </a:r>
-                      <a:endParaRPr lang="en-US" sz="950" dirty="0">
+                      <a:endParaRPr lang="en-US" sz="1150" dirty="0">
                         <a:latin typeface="Montserrat" charset="0"/>
                         <a:ea typeface="Montserrat" charset="0"/>
                         <a:cs typeface="Montserrat" charset="0"/>
@@ -22502,7 +22564,7 @@
                         <a:buNone/>
                       </a:pPr>
                       <a:r>
-                        <a:rPr lang="en-US" sz="950" dirty="0">
+                        <a:rPr lang="en-US" sz="1150" dirty="0">
                           <a:solidFill>
                             <a:srgbClr val="16181D"/>
                           </a:solidFill>
@@ -22512,7 +22574,7 @@
                         </a:rPr>
                         <a:t>32 / 64 / 128</a:t>
                       </a:r>
-                      <a:endParaRPr lang="en-US" sz="950" dirty="0">
+                      <a:endParaRPr lang="en-US" sz="1150" dirty="0">
                         <a:latin typeface="Montserrat" charset="0"/>
                         <a:ea typeface="Montserrat" charset="0"/>
                         <a:cs typeface="Montserrat" charset="0"/>
@@ -22570,7 +22632,7 @@
                         <a:buNone/>
                       </a:pPr>
                       <a:r>
-                        <a:rPr lang="en-US" sz="950" dirty="0">
+                        <a:rPr lang="en-US" sz="1150" dirty="0">
                           <a:solidFill>
                             <a:srgbClr val="16181D"/>
                           </a:solidFill>
@@ -22580,7 +22642,7 @@
                         </a:rPr>
                         <a:t>100</a:t>
                       </a:r>
-                      <a:endParaRPr lang="en-US" sz="950" dirty="0">
+                      <a:endParaRPr lang="en-US" sz="1150" dirty="0">
                         <a:latin typeface="Montserrat" charset="0"/>
                         <a:ea typeface="Montserrat" charset="0"/>
                         <a:cs typeface="Montserrat" charset="0"/>
@@ -22640,7 +22702,7 @@
                         <a:buNone/>
                       </a:pPr>
                       <a:r>
-                        <a:rPr lang="en-US" sz="950" b="1" dirty="0">
+                        <a:rPr lang="en-US" sz="1150" b="1" dirty="0">
                           <a:solidFill>
                             <a:srgbClr val="16181D"/>
                           </a:solidFill>
@@ -22650,7 +22712,7 @@
                         </a:rPr>
                         <a:t>Set intersection</a:t>
                       </a:r>
-                      <a:endParaRPr lang="en-US" sz="950" dirty="0">
+                      <a:endParaRPr lang="en-US" sz="1150" dirty="0">
                         <a:latin typeface="Montserrat" charset="0"/>
                         <a:ea typeface="Montserrat" charset="0"/>
                         <a:cs typeface="Montserrat" charset="0"/>
@@ -22708,7 +22770,7 @@
                         <a:buNone/>
                       </a:pPr>
                       <a:r>
-                        <a:rPr lang="en-US" sz="950" dirty="0">
+                        <a:rPr lang="en-US" sz="1150" dirty="0">
                           <a:solidFill>
                             <a:srgbClr val="16181D"/>
                           </a:solidFill>
@@ -22718,7 +22780,7 @@
                         </a:rPr>
                         <a:t>two sets, 25-75% overlap</a:t>
                       </a:r>
-                      <a:endParaRPr lang="en-US" sz="950" dirty="0">
+                      <a:endParaRPr lang="en-US" sz="1150" dirty="0">
                         <a:latin typeface="Montserrat" charset="0"/>
                         <a:ea typeface="Montserrat" charset="0"/>
                         <a:cs typeface="Montserrat" charset="0"/>
@@ -22776,7 +22838,7 @@
                         <a:buNone/>
                       </a:pPr>
                       <a:r>
-                        <a:rPr lang="en-US" sz="950" dirty="0">
+                        <a:rPr lang="en-US" sz="1150" dirty="0">
                           <a:solidFill>
                             <a:srgbClr val="16181D"/>
                           </a:solidFill>
@@ -22786,7 +22848,7 @@
                         </a:rPr>
                         <a:t>32 / 64 / 128</a:t>
                       </a:r>
-                      <a:endParaRPr lang="en-US" sz="950" dirty="0">
+                      <a:endParaRPr lang="en-US" sz="1150" dirty="0">
                         <a:latin typeface="Montserrat" charset="0"/>
                         <a:ea typeface="Montserrat" charset="0"/>
                         <a:cs typeface="Montserrat" charset="0"/>
@@ -22844,7 +22906,7 @@
                         <a:buNone/>
                       </a:pPr>
                       <a:r>
-                        <a:rPr lang="en-US" sz="950" dirty="0">
+                        <a:rPr lang="en-US" sz="1150" dirty="0">
                           <a:solidFill>
                             <a:srgbClr val="16181D"/>
                           </a:solidFill>
@@ -22854,7 +22916,7 @@
                         </a:rPr>
                         <a:t>100</a:t>
                       </a:r>
-                      <a:endParaRPr lang="en-US" sz="950" dirty="0">
+                      <a:endParaRPr lang="en-US" sz="1150" dirty="0">
                         <a:latin typeface="Montserrat" charset="0"/>
                         <a:ea typeface="Montserrat" charset="0"/>
                         <a:cs typeface="Montserrat" charset="0"/>
@@ -22914,7 +22976,7 @@
                         <a:buNone/>
                       </a:pPr>
                       <a:r>
-                        <a:rPr lang="en-US" sz="950" b="1" dirty="0">
+                        <a:rPr lang="en-US" sz="1150" b="1" dirty="0">
                           <a:solidFill>
                             <a:srgbClr val="16181D"/>
                           </a:solidFill>
@@ -22924,7 +22986,7 @@
                         </a:rPr>
                         <a:t>Keyword counting</a:t>
                       </a:r>
-                      <a:endParaRPr lang="en-US" sz="950" dirty="0">
+                      <a:endParaRPr lang="en-US" sz="1150" dirty="0">
                         <a:latin typeface="Montserrat" charset="0"/>
                         <a:ea typeface="Montserrat" charset="0"/>
                         <a:cs typeface="Montserrat" charset="0"/>
@@ -22982,7 +23044,7 @@
                         <a:buNone/>
                       </a:pPr>
                       <a:r>
-                        <a:rPr lang="en-US" sz="950" dirty="0">
+                        <a:rPr lang="en-US" sz="1150" dirty="0">
                           <a:solidFill>
                             <a:srgbClr val="16181D"/>
                           </a:solidFill>
@@ -22992,7 +23054,7 @@
                         </a:rPr>
                         <a:t>country mentions in text</a:t>
                       </a:r>
-                      <a:endParaRPr lang="en-US" sz="950" dirty="0">
+                      <a:endParaRPr lang="en-US" sz="1150" dirty="0">
                         <a:latin typeface="Montserrat" charset="0"/>
                         <a:ea typeface="Montserrat" charset="0"/>
                         <a:cs typeface="Montserrat" charset="0"/>
@@ -23050,7 +23112,7 @@
                         <a:buNone/>
                       </a:pPr>
                       <a:r>
-                        <a:rPr lang="en-US" sz="950" dirty="0">
+                        <a:rPr lang="en-US" sz="1150" dirty="0">
                           <a:solidFill>
                             <a:srgbClr val="16181D"/>
                           </a:solidFill>
@@ -23060,7 +23122,7 @@
                         </a:rPr>
                         <a:t>4 / 8 / 16 sentences</a:t>
                       </a:r>
-                      <a:endParaRPr lang="en-US" sz="950" dirty="0">
+                      <a:endParaRPr lang="en-US" sz="1150" dirty="0">
                         <a:latin typeface="Montserrat" charset="0"/>
                         <a:ea typeface="Montserrat" charset="0"/>
                         <a:cs typeface="Montserrat" charset="0"/>
@@ -23118,7 +23180,7 @@
                         <a:buNone/>
                       </a:pPr>
                       <a:r>
-                        <a:rPr lang="en-US" sz="950" dirty="0">
+                        <a:rPr lang="en-US" sz="1150" dirty="0">
                           <a:solidFill>
                             <a:srgbClr val="16181D"/>
                           </a:solidFill>
@@ -23128,7 +23190,7 @@
                         </a:rPr>
                         <a:t>-</a:t>
                       </a:r>
-                      <a:endParaRPr lang="en-US" sz="950" dirty="0">
+                      <a:endParaRPr lang="en-US" sz="1150" dirty="0">
                         <a:latin typeface="Montserrat" charset="0"/>
                         <a:ea typeface="Montserrat" charset="0"/>
                         <a:cs typeface="Montserrat" charset="0"/>
@@ -23188,7 +23250,7 @@
                         <a:buNone/>
                       </a:pPr>
                       <a:r>
-                        <a:rPr lang="en-US" sz="950" b="1" dirty="0">
+                        <a:rPr lang="en-US" sz="1150" b="1" dirty="0">
                           <a:solidFill>
                             <a:srgbClr val="16181D"/>
                           </a:solidFill>
@@ -23198,7 +23260,7 @@
                         </a:rPr>
                         <a:t>Document merging</a:t>
                       </a:r>
-                      <a:endParaRPr lang="en-US" sz="950" dirty="0">
+                      <a:endParaRPr lang="en-US" sz="1150" dirty="0">
                         <a:latin typeface="Montserrat" charset="0"/>
                         <a:ea typeface="Montserrat" charset="0"/>
                         <a:cs typeface="Montserrat" charset="0"/>
@@ -23256,7 +23318,7 @@
                         <a:buNone/>
                       </a:pPr>
                       <a:r>
-                        <a:rPr lang="en-US" sz="950" dirty="0">
+                        <a:rPr lang="en-US" sz="1150" dirty="0">
                           <a:solidFill>
                             <a:srgbClr val="16181D"/>
                           </a:solidFill>
@@ -23266,7 +23328,7 @@
                         </a:rPr>
                         <a:t>overlapping NDA documents</a:t>
                       </a:r>
-                      <a:endParaRPr lang="en-US" sz="950" dirty="0">
+                      <a:endParaRPr lang="en-US" sz="1150" dirty="0">
                         <a:latin typeface="Montserrat" charset="0"/>
                         <a:ea typeface="Montserrat" charset="0"/>
                         <a:cs typeface="Montserrat" charset="0"/>
@@ -23324,7 +23386,7 @@
                         <a:buNone/>
                       </a:pPr>
                       <a:r>
-                        <a:rPr lang="en-US" sz="950" dirty="0">
+                        <a:rPr lang="en-US" sz="1150" dirty="0">
                           <a:solidFill>
                             <a:srgbClr val="16181D"/>
                           </a:solidFill>
@@ -23334,7 +23396,7 @@
                         </a:rPr>
                         <a:t>4 documents</a:t>
                       </a:r>
-                      <a:endParaRPr lang="en-US" sz="950" dirty="0">
+                      <a:endParaRPr lang="en-US" sz="1150" dirty="0">
                         <a:latin typeface="Montserrat" charset="0"/>
                         <a:ea typeface="Montserrat" charset="0"/>
                         <a:cs typeface="Montserrat" charset="0"/>
@@ -23392,7 +23454,7 @@
                         <a:buNone/>
                       </a:pPr>
                       <a:r>
-                        <a:rPr lang="en-US" sz="950" dirty="0">
+                        <a:rPr lang="en-US" sz="1150" dirty="0">
                           <a:solidFill>
                             <a:srgbClr val="16181D"/>
                           </a:solidFill>
@@ -23402,7 +23464,7 @@
                         </a:rPr>
                         <a:t>-</a:t>
                       </a:r>
-                      <a:endParaRPr lang="en-US" sz="950" dirty="0">
+                      <a:endParaRPr lang="en-US" sz="1150" dirty="0">
                         <a:latin typeface="Montserrat" charset="0"/>
                         <a:ea typeface="Montserrat" charset="0"/>
                         <a:cs typeface="Montserrat" charset="0"/>
@@ -23481,7 +23543,7 @@
               <a:buNone/>
             </a:pPr>
             <a:r>
-              <a:rPr lang="en-US" sz="1000" i="1" dirty="0">
+              <a:rPr lang="en-US" sz="1200" i="1" dirty="0">
                 <a:solidFill>
                   <a:srgbClr val="63697A"/>
                 </a:solidFill>
@@ -23491,7 +23553,7 @@
               </a:rPr>
               <a:t>Run on the authors' own published CSV files, byte for byte - eliminating differing random data as an explanation for any discrepancy.</a:t>
             </a:r>
-            <a:endParaRPr lang="en-US" sz="1000" dirty="0"/>
+            <a:endParaRPr lang="en-US" sz="1200" dirty="0"/>
           </a:p>
         </p:txBody>
       </p:sp>
@@ -23520,7 +23582,7 @@
               <a:buNone/>
             </a:pPr>
             <a:r>
-              <a:rPr lang="en-US" sz="1450" b="1" dirty="0">
+              <a:rPr lang="en-US" sz="1550" b="1" dirty="0">
                 <a:solidFill>
                   <a:srgbClr val="23408E"/>
                 </a:solidFill>
@@ -23530,7 +23592,7 @@
               </a:rPr>
               <a:t>4) Models and infrastructure</a:t>
             </a:r>
-            <a:endParaRPr lang="en-US" sz="1450" dirty="0"/>
+            <a:endParaRPr lang="en-US" sz="1550" dirty="0"/>
           </a:p>
         </p:txBody>
       </p:sp>
@@ -23570,7 +23632,7 @@
                       <a:pPr indent="0" marL="0">
                         <a:buNone/>
                       </a:pPr>
-                      <a:endParaRPr lang="en-US" sz="950" dirty="0">
+                      <a:endParaRPr lang="en-US" sz="1150" dirty="0">
                         <a:latin typeface="Montserrat" charset="0"/>
                         <a:ea typeface="Montserrat" charset="0"/>
                         <a:cs typeface="Montserrat" charset="0"/>
@@ -23628,7 +23690,7 @@
                         <a:buNone/>
                       </a:pPr>
                       <a:r>
-                        <a:rPr lang="en-US" sz="950" b="1" dirty="0">
+                        <a:rPr lang="en-US" sz="1150" b="1" dirty="0">
                           <a:solidFill>
                             <a:srgbClr val="FFFFFF"/>
                           </a:solidFill>
@@ -23638,7 +23700,7 @@
                         </a:rPr>
                         <a:t>Original paper</a:t>
                       </a:r>
-                      <a:endParaRPr lang="en-US" sz="950" dirty="0">
+                      <a:endParaRPr lang="en-US" sz="1150" dirty="0">
                         <a:latin typeface="Montserrat" charset="0"/>
                         <a:ea typeface="Montserrat" charset="0"/>
                         <a:cs typeface="Montserrat" charset="0"/>
@@ -23696,7 +23758,7 @@
                         <a:buNone/>
                       </a:pPr>
                       <a:r>
-                        <a:rPr lang="en-US" sz="950" b="1" dirty="0">
+                        <a:rPr lang="en-US" sz="1150" b="1" dirty="0">
                           <a:solidFill>
                             <a:srgbClr val="FFFFFF"/>
                           </a:solidFill>
@@ -23706,7 +23768,7 @@
                         </a:rPr>
                         <a:t>This work</a:t>
                       </a:r>
-                      <a:endParaRPr lang="en-US" sz="950" dirty="0">
+                      <a:endParaRPr lang="en-US" sz="1150" dirty="0">
                         <a:latin typeface="Montserrat" charset="0"/>
                         <a:ea typeface="Montserrat" charset="0"/>
                         <a:cs typeface="Montserrat" charset="0"/>
@@ -23766,7 +23828,7 @@
                         <a:buNone/>
                       </a:pPr>
                       <a:r>
-                        <a:rPr lang="en-US" sz="950" b="1" dirty="0">
+                        <a:rPr lang="en-US" sz="1150" b="1" dirty="0">
                           <a:solidFill>
                             <a:srgbClr val="16181D"/>
                           </a:solidFill>
@@ -23776,7 +23838,7 @@
                         </a:rPr>
                         <a:t>Model</a:t>
                       </a:r>
-                      <a:endParaRPr lang="en-US" sz="950" dirty="0">
+                      <a:endParaRPr lang="en-US" sz="1150" dirty="0">
                         <a:latin typeface="Montserrat" charset="0"/>
                         <a:ea typeface="Montserrat" charset="0"/>
                         <a:cs typeface="Montserrat" charset="0"/>
@@ -23834,7 +23896,7 @@
                         <a:buNone/>
                       </a:pPr>
                       <a:r>
-                        <a:rPr lang="en-US" sz="950" dirty="0">
+                        <a:rPr lang="en-US" sz="1150" dirty="0">
                           <a:solidFill>
                             <a:srgbClr val="16181D"/>
                           </a:solidFill>
@@ -23844,7 +23906,7 @@
                         </a:rPr>
                         <a:t>ChatGPT-3.5 (closed API)</a:t>
                       </a:r>
-                      <a:endParaRPr lang="en-US" sz="950" dirty="0">
+                      <a:endParaRPr lang="en-US" sz="1150" dirty="0">
                         <a:latin typeface="Montserrat" charset="0"/>
                         <a:ea typeface="Montserrat" charset="0"/>
                         <a:cs typeface="Montserrat" charset="0"/>
@@ -23902,7 +23964,7 @@
                         <a:buNone/>
                       </a:pPr>
                       <a:r>
-                        <a:rPr lang="en-US" sz="950" dirty="0">
+                        <a:rPr lang="en-US" sz="1150" dirty="0">
                           <a:solidFill>
                             <a:srgbClr val="16181D"/>
                           </a:solidFill>
@@ -23912,7 +23974,7 @@
                         </a:rPr>
                         <a:t>Qwen2.5-7B-Instruct (open)</a:t>
                       </a:r>
-                      <a:endParaRPr lang="en-US" sz="950" dirty="0">
+                      <a:endParaRPr lang="en-US" sz="1150" dirty="0">
                         <a:latin typeface="Montserrat" charset="0"/>
                         <a:ea typeface="Montserrat" charset="0"/>
                         <a:cs typeface="Montserrat" charset="0"/>
@@ -23972,7 +24034,7 @@
                         <a:buNone/>
                       </a:pPr>
                       <a:r>
-                        <a:rPr lang="en-US" sz="950" b="1" dirty="0">
+                        <a:rPr lang="en-US" sz="1150" b="1" dirty="0">
                           <a:solidFill>
                             <a:srgbClr val="16181D"/>
                           </a:solidFill>
@@ -23982,7 +24044,7 @@
                         </a:rPr>
                         <a:t>Serving</a:t>
                       </a:r>
-                      <a:endParaRPr lang="en-US" sz="950" dirty="0">
+                      <a:endParaRPr lang="en-US" sz="1150" dirty="0">
                         <a:latin typeface="Montserrat" charset="0"/>
                         <a:ea typeface="Montserrat" charset="0"/>
                         <a:cs typeface="Montserrat" charset="0"/>
@@ -24040,7 +24102,7 @@
                         <a:buNone/>
                       </a:pPr>
                       <a:r>
-                        <a:rPr lang="en-US" sz="950" dirty="0">
+                        <a:rPr lang="en-US" sz="1150" dirty="0">
                           <a:solidFill>
                             <a:srgbClr val="16181D"/>
                           </a:solidFill>
@@ -24050,7 +24112,7 @@
                         </a:rPr>
                         <a:t>Vendor API</a:t>
                       </a:r>
-                      <a:endParaRPr lang="en-US" sz="950" dirty="0">
+                      <a:endParaRPr lang="en-US" sz="1150" dirty="0">
                         <a:latin typeface="Montserrat" charset="0"/>
                         <a:ea typeface="Montserrat" charset="0"/>
                         <a:cs typeface="Montserrat" charset="0"/>
@@ -24108,7 +24170,7 @@
                         <a:buNone/>
                       </a:pPr>
                       <a:r>
-                        <a:rPr lang="en-US" sz="950" dirty="0">
+                        <a:rPr lang="en-US" sz="1150" dirty="0">
                           <a:solidFill>
                             <a:srgbClr val="16181D"/>
                           </a:solidFill>
@@ -24118,7 +24180,7 @@
                         </a:rPr>
                         <a:t>vLLM on NVIDIA RTX A6000</a:t>
                       </a:r>
-                      <a:endParaRPr lang="en-US" sz="950" dirty="0">
+                      <a:endParaRPr lang="en-US" sz="1150" dirty="0">
                         <a:latin typeface="Montserrat" charset="0"/>
                         <a:ea typeface="Montserrat" charset="0"/>
                         <a:cs typeface="Montserrat" charset="0"/>
@@ -24178,7 +24240,7 @@
                         <a:buNone/>
                       </a:pPr>
                       <a:r>
-                        <a:rPr lang="en-US" sz="950" b="1" dirty="0">
+                        <a:rPr lang="en-US" sz="1150" b="1" dirty="0">
                           <a:solidFill>
                             <a:srgbClr val="16181D"/>
                           </a:solidFill>
@@ -24188,7 +24250,7 @@
                         </a:rPr>
                         <a:t>Sampling</a:t>
                       </a:r>
-                      <a:endParaRPr lang="en-US" sz="950" dirty="0">
+                      <a:endParaRPr lang="en-US" sz="1150" dirty="0">
                         <a:latin typeface="Montserrat" charset="0"/>
                         <a:ea typeface="Montserrat" charset="0"/>
                         <a:cs typeface="Montserrat" charset="0"/>
@@ -24246,7 +24308,7 @@
                         <a:buNone/>
                       </a:pPr>
                       <a:r>
-                        <a:rPr lang="en-US" sz="950" dirty="0">
+                        <a:rPr lang="en-US" sz="1150" dirty="0">
                           <a:solidFill>
                             <a:srgbClr val="16181D"/>
                           </a:solidFill>
@@ -24256,7 +24318,7 @@
                         </a:rPr>
                         <a:t>Temperature 1.0, 4k context</a:t>
                       </a:r>
-                      <a:endParaRPr lang="en-US" sz="950" dirty="0">
+                      <a:endParaRPr lang="en-US" sz="1150" dirty="0">
                         <a:latin typeface="Montserrat" charset="0"/>
                         <a:ea typeface="Montserrat" charset="0"/>
                         <a:cs typeface="Montserrat" charset="0"/>
@@ -24314,7 +24376,7 @@
                         <a:buNone/>
                       </a:pPr>
                       <a:r>
-                        <a:rPr lang="en-US" sz="950" dirty="0">
+                        <a:rPr lang="en-US" sz="1150" dirty="0">
                           <a:solidFill>
                             <a:srgbClr val="16181D"/>
                           </a:solidFill>
@@ -24324,7 +24386,7 @@
                         </a:rPr>
                         <a:t>Identical</a:t>
                       </a:r>
-                      <a:endParaRPr lang="en-US" sz="950" dirty="0">
+                      <a:endParaRPr lang="en-US" sz="1150" dirty="0">
                         <a:latin typeface="Montserrat" charset="0"/>
                         <a:ea typeface="Montserrat" charset="0"/>
                         <a:cs typeface="Montserrat" charset="0"/>
@@ -24384,7 +24446,7 @@
                         <a:buNone/>
                       </a:pPr>
                       <a:r>
-                        <a:rPr lang="en-US" sz="950" b="1" dirty="0">
+                        <a:rPr lang="en-US" sz="1150" b="1" dirty="0">
                           <a:solidFill>
                             <a:srgbClr val="16181D"/>
                           </a:solidFill>
@@ -24394,7 +24456,7 @@
                         </a:rPr>
                         <a:t>Samples</a:t>
                       </a:r>
-                      <a:endParaRPr lang="en-US" sz="950" dirty="0">
+                      <a:endParaRPr lang="en-US" sz="1150" dirty="0">
                         <a:latin typeface="Montserrat" charset="0"/>
                         <a:ea typeface="Montserrat" charset="0"/>
                         <a:cs typeface="Montserrat" charset="0"/>
@@ -24452,7 +24514,7 @@
                         <a:buNone/>
                       </a:pPr>
                       <a:r>
-                        <a:rPr lang="en-US" sz="950" dirty="0">
+                        <a:rPr lang="en-US" sz="1150" dirty="0">
                           <a:solidFill>
                             <a:srgbClr val="16181D"/>
                           </a:solidFill>
@@ -24462,7 +24524,7 @@
                         </a:rPr>
                         <a:t>100 per configuration</a:t>
                       </a:r>
-                      <a:endParaRPr lang="en-US" sz="950" dirty="0">
+                      <a:endParaRPr lang="en-US" sz="1150" dirty="0">
                         <a:latin typeface="Montserrat" charset="0"/>
                         <a:ea typeface="Montserrat" charset="0"/>
                         <a:cs typeface="Montserrat" charset="0"/>
@@ -24520,7 +24582,7 @@
                         <a:buNone/>
                       </a:pPr>
                       <a:r>
-                        <a:rPr lang="en-US" sz="950" dirty="0">
+                        <a:rPr lang="en-US" sz="1150" dirty="0">
                           <a:solidFill>
                             <a:srgbClr val="16181D"/>
                           </a:solidFill>
@@ -24530,7 +24592,7 @@
                         </a:rPr>
                         <a:t>100 per configuration</a:t>
                       </a:r>
-                      <a:endParaRPr lang="en-US" sz="950" dirty="0">
+                      <a:endParaRPr lang="en-US" sz="1150" dirty="0">
                         <a:latin typeface="Montserrat" charset="0"/>
                         <a:ea typeface="Montserrat" charset="0"/>
                         <a:cs typeface="Montserrat" charset="0"/>
@@ -24636,7 +24698,7 @@
               <a:buNone/>
             </a:pPr>
             <a:r>
-              <a:rPr lang="en-US" sz="1150" b="1" dirty="0">
+              <a:rPr lang="en-US" sz="1300" b="1" dirty="0">
                 <a:solidFill>
                   <a:srgbClr val="23408E"/>
                 </a:solidFill>
@@ -24646,7 +24708,7 @@
               </a:rPr>
               <a:t>Experimental control</a:t>
             </a:r>
-            <a:endParaRPr lang="en-US" sz="1150" dirty="0"/>
+            <a:endParaRPr lang="en-US" sz="1300" dirty="0"/>
           </a:p>
         </p:txBody>
       </p:sp>
@@ -24675,7 +24737,7 @@
               <a:buNone/>
             </a:pPr>
             <a:r>
-              <a:rPr lang="en-US" sz="1050" dirty="0">
+              <a:rPr lang="en-US" sz="1300" dirty="0">
                 <a:solidFill>
                   <a:srgbClr val="16181D"/>
                 </a:solidFill>
@@ -24685,7 +24747,7 @@
               </a:rPr>
               <a:t>All five schemes share one controller, one backend, one prompt set and one scorer.</a:t>
             </a:r>
-            <a:endParaRPr lang="en-US" sz="1050" dirty="0"/>
+            <a:endParaRPr lang="en-US" sz="1300" dirty="0"/>
           </a:p>
         </p:txBody>
       </p:sp>
@@ -24714,7 +24776,7 @@
               <a:buNone/>
             </a:pPr>
             <a:r>
-              <a:rPr lang="en-US" sz="1050" b="1" dirty="0">
+              <a:rPr lang="en-US" sz="1200" b="1" dirty="0">
                 <a:solidFill>
                   <a:srgbClr val="D98A1F"/>
                 </a:solidFill>
@@ -24724,7 +24786,7 @@
               </a:rPr>
               <a:t>Any measured difference is therefore attributable to graph structure alone.</a:t>
             </a:r>
-            <a:endParaRPr lang="en-US" sz="1050" dirty="0"/>
+            <a:endParaRPr lang="en-US" sz="1200" dirty="0"/>
           </a:p>
         </p:txBody>
       </p:sp>
@@ -24792,7 +24854,7 @@
               <a:buNone/>
             </a:pPr>
             <a:r>
-              <a:rPr lang="en-US" sz="900" dirty="0">
+              <a:rPr lang="en-US" sz="1000" dirty="0">
                 <a:solidFill>
                   <a:srgbClr val="63697A"/>
                 </a:solidFill>
@@ -24802,7 +24864,7 @@
               </a:rPr>
               <a:t>schemes on one engine</a:t>
             </a:r>
-            <a:endParaRPr lang="en-US" sz="900" dirty="0"/>
+            <a:endParaRPr lang="en-US" sz="1000" dirty="0"/>
           </a:p>
         </p:txBody>
       </p:sp>
@@ -24870,7 +24932,7 @@
               <a:buNone/>
             </a:pPr>
             <a:r>
-              <a:rPr lang="en-US" sz="900" dirty="0">
+              <a:rPr lang="en-US" sz="1000" dirty="0">
                 <a:solidFill>
                   <a:srgbClr val="63697A"/>
                 </a:solidFill>
@@ -24880,7 +24942,7 @@
               </a:rPr>
               <a:t>interchangeable backends</a:t>
             </a:r>
-            <a:endParaRPr lang="en-US" sz="900" dirty="0"/>
+            <a:endParaRPr lang="en-US" sz="1000" dirty="0"/>
           </a:p>
         </p:txBody>
       </p:sp>
@@ -24948,7 +25010,7 @@
               <a:buNone/>
             </a:pPr>
             <a:r>
-              <a:rPr lang="en-US" sz="900" dirty="0">
+              <a:rPr lang="en-US" sz="1000" dirty="0">
                 <a:solidFill>
                   <a:srgbClr val="63697A"/>
                 </a:solidFill>
@@ -24958,7 +25020,7 @@
               </a:rPr>
               <a:t>automated tests per run</a:t>
             </a:r>
-            <a:endParaRPr lang="en-US" sz="900" dirty="0"/>
+            <a:endParaRPr lang="en-US" sz="1000" dirty="0"/>
           </a:p>
         </p:txBody>
       </p:sp>

</xml_diff>